<commit_message>
Rework director deck: friction/solution/ROI narrative with pilot ask
Co-Authored-By: Claude Fable 5 <noreply@anthropic.com>
Claude-Session: https://claude.ai/code/session_01CurgSAtVqf52A9cVJVF6K6
</commit_message>
<xml_diff>
--- a/PrimeNet_Director_Presentation.pptx
+++ b/PrimeNet_Director_Presentation.pptx
@@ -504,7 +504,7 @@
           <a:p>
             <a:r>
               <a:rPr lang="en-US" dirty="0"/>
-              <a:t>Frame the pain: two vendors, four radio generations, every dataset in a different format and tool. Engineering effort goes into collecting and reconciling data instead of acting on it, and problems are found reactively.</a:t>
+              <a:t>Pitch: "Right now, our telecom engineering department is drowning in vendor-specific silos. Engineers waste up to 40% of their day logging into separate, incompatible platforms just to manage multi-vendor, multi-RAT networks. This fragmentation delays network optimization and spikes operational costs." (Source: FNT Software — The Challenge of Fragmented Systems.) Directors hate operational silos and wasted engineering hours — establish the massive inefficiency before showing the fix.</a:t>
             </a:r>
             <a:endParaRPr lang="en-US" dirty="0"/>
           </a:p>
@@ -592,7 +592,7 @@
           <a:p>
             <a:r>
               <a:rPr lang="en-US" dirty="0"/>
-              <a:t>PrimeNet is our in-house web platform: an automated pipeline pulls performance and configuration data from both vendors into one unified database, and ~40 tools sit on top of it behind a single secure login. Walk the flow left, then the four capability families right.</a:t>
+              <a:t>Pitch: "We built PrimeNet. It is a single, web-based interface that consolidates multi-vendor and multi-RAT engineering functionalities into one dashboard. It strips away technical complexity, allowing engineers to monitor, configure, and optimize everything in one place, regardless of the hardware provider." Walk the diagram left to right: raw multi-vendor data in, PrimeNet engine in the middle, one unified interface out. Emphasize scalability — the engine is vendor- and RAT-agnostic by design.</a:t>
             </a:r>
             <a:endParaRPr lang="en-US" dirty="0"/>
           </a:p>
@@ -680,7 +680,7 @@
           <a:p>
             <a:r>
               <a:rPr lang="en-US" dirty="0"/>
-              <a:t>Close on value: one pane of glass across vendors and technologies, proactive detection instead of firefighting, real engineering hours saved, and full independence — self-hosted, no vendor license fees, extensible in-house.</a:t>
+              <a:t>Pitch: "By deploying PrimeNet internally, we will instantly cut engineering cycle times and reduce vendor software licensing fees. But the real play is commercial: we are architecting PrimeNet to scale into a standalone, integrated system that we can license to global telecom operators, turning a cost center into a major revenue stream. To hit Phase 1, I need your green light to launch a 30-day pilot with [X team]." Directors invest when they see immediate internal ROI coupled with a massive external market upside — land the ask explicitly. Replace [X team] with the actual pilot team before presenting.</a:t>
             </a:r>
             <a:endParaRPr lang="en-US" dirty="0"/>
           </a:p>
@@ -1062,7 +1062,7 @@
         <p:spPr>
           <a:xfrm>
             <a:off x="548640" y="384048"/>
-            <a:ext cx="5486400" cy="320040"/>
+            <a:ext cx="8229600" cy="320040"/>
           </a:xfrm>
           <a:prstGeom prst="rect">
             <a:avLst/>
@@ -1086,7 +1086,7 @@
                 <a:ea typeface="Calibri" pitchFamily="34" charset="-122"/>
                 <a:cs typeface="Calibri" pitchFamily="34" charset="-120"/>
               </a:rPr>
-              <a:t>THE PROBLEM</a:t>
+              <a:t>THE FRICTION — THE COST OF FRAGMENTATION</a:t>
             </a:r>
             <a:endParaRPr lang="en-US" sz="1300" dirty="0"/>
           </a:p>
@@ -1101,7 +1101,7 @@
         <p:spPr>
           <a:xfrm>
             <a:off x="548640" y="713232"/>
-            <a:ext cx="11064240" cy="777240"/>
+            <a:ext cx="11064240" cy="685800"/>
           </a:xfrm>
           <a:prstGeom prst="rect">
             <a:avLst/>
@@ -1117,7 +1117,7 @@
               <a:buNone/>
             </a:pPr>
             <a:r>
-              <a:rPr lang="en-US" sz="3700" b="1" dirty="0">
+              <a:rPr lang="en-US" sz="3400" b="1" dirty="0">
                 <a:solidFill>
                   <a:srgbClr val="FFFFFF"/>
                 </a:solidFill>
@@ -1125,9 +1125,9 @@
                 <a:ea typeface="Calibri" pitchFamily="34" charset="-122"/>
                 <a:cs typeface="Calibri" pitchFamily="34" charset="-120"/>
               </a:rPr>
-              <a:t>Running a Multi-Vendor Network in Fragments</a:t>
-            </a:r>
-            <a:endParaRPr lang="en-US" sz="3700" dirty="0"/>
+              <a:t>The Fragmented Telecom Workflow Liability</a:t>
+            </a:r>
+            <a:endParaRPr lang="en-US" sz="3400" dirty="0"/>
           </a:p>
         </p:txBody>
       </p:sp>
@@ -1139,74 +1139,311 @@
         </p:nvSpPr>
         <p:spPr>
           <a:xfrm>
-            <a:off x="548640" y="1783080"/>
-            <a:ext cx="5376672" cy="1847088"/>
+            <a:off x="1440180" y="2423160"/>
+            <a:ext cx="0" cy="1280160"/>
+          </a:xfrm>
+          <a:prstGeom prst="line">
+            <a:avLst/>
+          </a:prstGeom>
+          <a:noFill/>
+          <a:ln w="12700">
+            <a:solidFill>
+              <a:srgbClr val="5A66A0"/>
+            </a:solidFill>
+            <a:prstDash val="solid"/>
+          </a:ln>
+        </p:spPr>
+      </p:sp>
+      <p:sp>
+        <p:nvSpPr>
+          <p:cNvPr id="5" name="Shape 3"/>
+          <p:cNvSpPr/>
+          <p:nvPr/>
+        </p:nvSpPr>
+        <p:spPr>
+          <a:xfrm>
+            <a:off x="1440180" y="2423160"/>
+            <a:ext cx="1938528" cy="1280160"/>
+          </a:xfrm>
+          <a:prstGeom prst="line">
+            <a:avLst/>
+          </a:prstGeom>
+          <a:noFill/>
+          <a:ln w="12700">
+            <a:solidFill>
+              <a:srgbClr val="5A66A0"/>
+            </a:solidFill>
+            <a:prstDash val="solid"/>
+          </a:ln>
+        </p:spPr>
+      </p:sp>
+      <p:sp>
+        <p:nvSpPr>
+          <p:cNvPr id="6" name="Shape 4"/>
+          <p:cNvSpPr/>
+          <p:nvPr/>
+        </p:nvSpPr>
+        <p:spPr>
+          <a:xfrm>
+            <a:off x="1440180" y="2423160"/>
+            <a:ext cx="3877056" cy="1280160"/>
+          </a:xfrm>
+          <a:prstGeom prst="line">
+            <a:avLst/>
+          </a:prstGeom>
+          <a:noFill/>
+          <a:ln w="12700">
+            <a:solidFill>
+              <a:srgbClr val="5A66A0"/>
+            </a:solidFill>
+            <a:prstDash val="solid"/>
+          </a:ln>
+        </p:spPr>
+      </p:sp>
+      <p:sp>
+        <p:nvSpPr>
+          <p:cNvPr id="7" name="Shape 5"/>
+          <p:cNvSpPr/>
+          <p:nvPr/>
+        </p:nvSpPr>
+        <p:spPr>
+          <a:xfrm flipV="1">
+            <a:off x="1440180" y="2423160"/>
+            <a:ext cx="1938528" cy="1280160"/>
+          </a:xfrm>
+          <a:prstGeom prst="line">
+            <a:avLst/>
+          </a:prstGeom>
+          <a:noFill/>
+          <a:ln w="12700">
+            <a:solidFill>
+              <a:srgbClr val="5A66A0"/>
+            </a:solidFill>
+            <a:prstDash val="solid"/>
+          </a:ln>
+        </p:spPr>
+      </p:sp>
+      <p:sp>
+        <p:nvSpPr>
+          <p:cNvPr id="8" name="Shape 6"/>
+          <p:cNvSpPr/>
+          <p:nvPr/>
+        </p:nvSpPr>
+        <p:spPr>
+          <a:xfrm>
+            <a:off x="3378708" y="2423160"/>
+            <a:ext cx="0" cy="1280160"/>
+          </a:xfrm>
+          <a:prstGeom prst="line">
+            <a:avLst/>
+          </a:prstGeom>
+          <a:noFill/>
+          <a:ln w="12700">
+            <a:solidFill>
+              <a:srgbClr val="5A66A0"/>
+            </a:solidFill>
+            <a:prstDash val="solid"/>
+          </a:ln>
+        </p:spPr>
+      </p:sp>
+      <p:sp>
+        <p:nvSpPr>
+          <p:cNvPr id="9" name="Shape 7"/>
+          <p:cNvSpPr/>
+          <p:nvPr/>
+        </p:nvSpPr>
+        <p:spPr>
+          <a:xfrm>
+            <a:off x="3378708" y="2423160"/>
+            <a:ext cx="1938528" cy="1280160"/>
+          </a:xfrm>
+          <a:prstGeom prst="line">
+            <a:avLst/>
+          </a:prstGeom>
+          <a:noFill/>
+          <a:ln w="12700">
+            <a:solidFill>
+              <a:srgbClr val="5A66A0"/>
+            </a:solidFill>
+            <a:prstDash val="solid"/>
+          </a:ln>
+        </p:spPr>
+      </p:sp>
+      <p:sp>
+        <p:nvSpPr>
+          <p:cNvPr id="10" name="Shape 8"/>
+          <p:cNvSpPr/>
+          <p:nvPr/>
+        </p:nvSpPr>
+        <p:spPr>
+          <a:xfrm flipV="1">
+            <a:off x="1440180" y="2423160"/>
+            <a:ext cx="3877056" cy="1280160"/>
+          </a:xfrm>
+          <a:prstGeom prst="line">
+            <a:avLst/>
+          </a:prstGeom>
+          <a:noFill/>
+          <a:ln w="12700">
+            <a:solidFill>
+              <a:srgbClr val="5A66A0"/>
+            </a:solidFill>
+            <a:prstDash val="solid"/>
+          </a:ln>
+        </p:spPr>
+      </p:sp>
+      <p:sp>
+        <p:nvSpPr>
+          <p:cNvPr id="11" name="Shape 9"/>
+          <p:cNvSpPr/>
+          <p:nvPr/>
+        </p:nvSpPr>
+        <p:spPr>
+          <a:xfrm flipV="1">
+            <a:off x="3378708" y="2423160"/>
+            <a:ext cx="1938528" cy="1280160"/>
+          </a:xfrm>
+          <a:prstGeom prst="line">
+            <a:avLst/>
+          </a:prstGeom>
+          <a:noFill/>
+          <a:ln w="12700">
+            <a:solidFill>
+              <a:srgbClr val="5A66A0"/>
+            </a:solidFill>
+            <a:prstDash val="solid"/>
+          </a:ln>
+        </p:spPr>
+      </p:sp>
+      <p:sp>
+        <p:nvSpPr>
+          <p:cNvPr id="12" name="Shape 10"/>
+          <p:cNvSpPr/>
+          <p:nvPr/>
+        </p:nvSpPr>
+        <p:spPr>
+          <a:xfrm>
+            <a:off x="5317236" y="2423160"/>
+            <a:ext cx="0" cy="1280160"/>
+          </a:xfrm>
+          <a:prstGeom prst="line">
+            <a:avLst/>
+          </a:prstGeom>
+          <a:noFill/>
+          <a:ln w="12700">
+            <a:solidFill>
+              <a:srgbClr val="5A66A0"/>
+            </a:solidFill>
+            <a:prstDash val="solid"/>
+          </a:ln>
+        </p:spPr>
+      </p:sp>
+      <p:sp>
+        <p:nvSpPr>
+          <p:cNvPr id="13" name="Shape 11"/>
+          <p:cNvSpPr/>
+          <p:nvPr/>
+        </p:nvSpPr>
+        <p:spPr>
+          <a:xfrm>
+            <a:off x="1440180" y="4251960"/>
+            <a:ext cx="1938528" cy="822960"/>
+          </a:xfrm>
+          <a:prstGeom prst="line">
+            <a:avLst/>
+          </a:prstGeom>
+          <a:noFill/>
+          <a:ln w="19050">
+            <a:solidFill>
+              <a:srgbClr val="F96167"/>
+            </a:solidFill>
+            <a:prstDash val="solid"/>
+          </a:ln>
+        </p:spPr>
+      </p:sp>
+      <p:sp>
+        <p:nvSpPr>
+          <p:cNvPr id="14" name="Shape 12"/>
+          <p:cNvSpPr/>
+          <p:nvPr/>
+        </p:nvSpPr>
+        <p:spPr>
+          <a:xfrm>
+            <a:off x="3378708" y="4251960"/>
+            <a:ext cx="0" cy="822960"/>
+          </a:xfrm>
+          <a:prstGeom prst="line">
+            <a:avLst/>
+          </a:prstGeom>
+          <a:noFill/>
+          <a:ln w="19050">
+            <a:solidFill>
+              <a:srgbClr val="F96167"/>
+            </a:solidFill>
+            <a:prstDash val="solid"/>
+          </a:ln>
+        </p:spPr>
+      </p:sp>
+      <p:sp>
+        <p:nvSpPr>
+          <p:cNvPr id="15" name="Shape 13"/>
+          <p:cNvSpPr/>
+          <p:nvPr/>
+        </p:nvSpPr>
+        <p:spPr>
+          <a:xfrm flipV="1">
+            <a:off x="3378708" y="4251960"/>
+            <a:ext cx="1938528" cy="822960"/>
+          </a:xfrm>
+          <a:prstGeom prst="line">
+            <a:avLst/>
+          </a:prstGeom>
+          <a:noFill/>
+          <a:ln w="19050">
+            <a:solidFill>
+              <a:srgbClr val="F96167"/>
+            </a:solidFill>
+            <a:prstDash val="solid"/>
+          </a:ln>
+        </p:spPr>
+      </p:sp>
+      <p:sp>
+        <p:nvSpPr>
+          <p:cNvPr id="16" name="Shape 14"/>
+          <p:cNvSpPr/>
+          <p:nvPr/>
+        </p:nvSpPr>
+        <p:spPr>
+          <a:xfrm>
+            <a:off x="548640" y="1874520"/>
+            <a:ext cx="1783080" cy="548640"/>
           </a:xfrm>
           <a:prstGeom prst="roundRect">
             <a:avLst>
-              <a:gd name="adj" fmla="val 4455"/>
+              <a:gd name="adj" fmla="val 11667"/>
             </a:avLst>
           </a:prstGeom>
           <a:solidFill>
             <a:srgbClr val="2A3575"/>
           </a:solidFill>
-          <a:ln/>
-        </p:spPr>
-      </p:sp>
-      <p:sp>
-        <p:nvSpPr>
-          <p:cNvPr id="5" name="Shape 3"/>
-          <p:cNvSpPr/>
-          <p:nvPr/>
-        </p:nvSpPr>
-        <p:spPr>
-          <a:xfrm>
-            <a:off x="822960" y="2075688"/>
-            <a:ext cx="566928" cy="566928"/>
-          </a:xfrm>
-          <a:prstGeom prst="ellipse">
-            <a:avLst/>
-          </a:prstGeom>
-          <a:solidFill>
-            <a:srgbClr val="02C39A"/>
-          </a:solidFill>
-          <a:ln/>
-        </p:spPr>
-      </p:sp>
-      <p:pic>
-        <p:nvPicPr>
-          <p:cNvPr id="6" name="Image 0" descr="preencoded.png">    </p:cNvPr>
-          <p:cNvPicPr>
-            <a:picLocks noChangeAspect="1"/>
-          </p:cNvPicPr>
-          <p:nvPr/>
-        </p:nvPicPr>
-        <p:blipFill>
-          <a:blip r:embed="rId1"/>
-          <a:stretch>
-            <a:fillRect/>
-          </a:stretch>
-        </p:blipFill>
-        <p:spPr>
-          <a:xfrm>
-            <a:off x="959023" y="2211751"/>
-            <a:ext cx="294803" cy="294803"/>
-          </a:xfrm>
-          <a:prstGeom prst="rect">
-            <a:avLst/>
-          </a:prstGeom>
-        </p:spPr>
-      </p:pic>
-      <p:sp>
-        <p:nvSpPr>
-          <p:cNvPr id="7" name="Text 4"/>
-          <p:cNvSpPr/>
-          <p:nvPr/>
-        </p:nvSpPr>
-        <p:spPr>
-          <a:xfrm>
-            <a:off x="1600200" y="2057400"/>
-            <a:ext cx="4050792" cy="365760"/>
+          <a:ln w="9525">
+            <a:solidFill>
+              <a:srgbClr val="5A66A0"/>
+            </a:solidFill>
+            <a:prstDash val="solid"/>
+          </a:ln>
+        </p:spPr>
+      </p:sp>
+      <p:sp>
+        <p:nvSpPr>
+          <p:cNvPr id="17" name="Text 15"/>
+          <p:cNvSpPr/>
+          <p:nvPr/>
+        </p:nvSpPr>
+        <p:spPr>
+          <a:xfrm>
+            <a:off x="548640" y="1874520"/>
+            <a:ext cx="1783080" cy="548640"/>
           </a:xfrm>
           <a:prstGeom prst="rect">
             <a:avLst/>
@@ -1218,11 +1455,11 @@
           <a:bodyPr wrap="square" lIns="0" tIns="0" rIns="0" bIns="0" rtlCol="0" anchor="ctr"/>
           <a:lstStyle/>
           <a:p>
-            <a:pPr indent="0" marL="0">
-              <a:buNone/>
-            </a:pPr>
-            <a:r>
-              <a:rPr lang="en-US" sz="1650" b="1" dirty="0">
+            <a:pPr algn="ctr" indent="0" marL="0">
+              <a:buNone/>
+            </a:pPr>
+            <a:r>
+              <a:rPr lang="en-US" sz="1250" b="1" dirty="0">
                 <a:solidFill>
                   <a:srgbClr val="FFFFFF"/>
                 </a:solidFill>
@@ -1230,46 +1467,7 @@
                 <a:ea typeface="Calibri" pitchFamily="34" charset="-122"/>
                 <a:cs typeface="Calibri" pitchFamily="34" charset="-120"/>
               </a:rPr>
-              <a:t>Vendor &amp; technology silos</a:t>
-            </a:r>
-            <a:endParaRPr lang="en-US" sz="1650" dirty="0"/>
-          </a:p>
-        </p:txBody>
-      </p:sp>
-      <p:sp>
-        <p:nvSpPr>
-          <p:cNvPr id="8" name="Text 5"/>
-          <p:cNvSpPr/>
-          <p:nvPr/>
-        </p:nvSpPr>
-        <p:spPr>
-          <a:xfrm>
-            <a:off x="1600200" y="2459736"/>
-            <a:ext cx="4050792" cy="1051560"/>
-          </a:xfrm>
-          <a:prstGeom prst="rect">
-            <a:avLst/>
-          </a:prstGeom>
-          <a:noFill/>
-          <a:ln/>
-        </p:spPr>
-        <p:txBody>
-          <a:bodyPr wrap="square" lIns="0" tIns="0" rIns="0" bIns="0" rtlCol="0" anchor="t"/>
-          <a:lstStyle/>
-          <a:p>
-            <a:pPr indent="0" marL="0">
-              <a:buNone/>
-            </a:pPr>
-            <a:r>
-              <a:rPr lang="en-US" sz="1250" dirty="0">
-                <a:solidFill>
-                  <a:srgbClr val="CADCFC"/>
-                </a:solidFill>
-                <a:latin typeface="Calibri" pitchFamily="34" charset="0"/>
-                <a:ea typeface="Calibri" pitchFamily="34" charset="-122"/>
-                <a:cs typeface="Calibri" pitchFamily="34" charset="-120"/>
-              </a:rPr>
-              <a:t>Nokia and Huawei each ship their own counters, formats and tools — across 2G, 3G, 4G and 5G. There is no single view of the network.</a:t>
+              <a:t>Ericsson OSS</a:t>
             </a:r>
             <a:endParaRPr lang="en-US" sz="1250" dirty="0"/>
           </a:p>
@@ -1277,80 +1475,41 @@
       </p:sp>
       <p:sp>
         <p:nvSpPr>
-          <p:cNvPr id="9" name="Shape 6"/>
-          <p:cNvSpPr/>
-          <p:nvPr/>
-        </p:nvSpPr>
-        <p:spPr>
-          <a:xfrm>
-            <a:off x="6263640" y="1783080"/>
-            <a:ext cx="5376672" cy="1847088"/>
+          <p:cNvPr id="18" name="Shape 16"/>
+          <p:cNvSpPr/>
+          <p:nvPr/>
+        </p:nvSpPr>
+        <p:spPr>
+          <a:xfrm>
+            <a:off x="2487168" y="1874520"/>
+            <a:ext cx="1783080" cy="548640"/>
           </a:xfrm>
           <a:prstGeom prst="roundRect">
             <a:avLst>
-              <a:gd name="adj" fmla="val 4455"/>
+              <a:gd name="adj" fmla="val 11667"/>
             </a:avLst>
           </a:prstGeom>
           <a:solidFill>
             <a:srgbClr val="2A3575"/>
           </a:solidFill>
-          <a:ln/>
-        </p:spPr>
-      </p:sp>
-      <p:sp>
-        <p:nvSpPr>
-          <p:cNvPr id="10" name="Shape 7"/>
-          <p:cNvSpPr/>
-          <p:nvPr/>
-        </p:nvSpPr>
-        <p:spPr>
-          <a:xfrm>
-            <a:off x="6537960" y="2075688"/>
-            <a:ext cx="566928" cy="566928"/>
-          </a:xfrm>
-          <a:prstGeom prst="ellipse">
-            <a:avLst/>
-          </a:prstGeom>
-          <a:solidFill>
-            <a:srgbClr val="02C39A"/>
-          </a:solidFill>
-          <a:ln/>
-        </p:spPr>
-      </p:sp>
-      <p:pic>
-        <p:nvPicPr>
-          <p:cNvPr id="11" name="Image 1" descr="preencoded.png">    </p:cNvPr>
-          <p:cNvPicPr>
-            <a:picLocks noChangeAspect="1"/>
-          </p:cNvPicPr>
-          <p:nvPr/>
-        </p:nvPicPr>
-        <p:blipFill>
-          <a:blip r:embed="rId2"/>
-          <a:stretch>
-            <a:fillRect/>
-          </a:stretch>
-        </p:blipFill>
-        <p:spPr>
-          <a:xfrm>
-            <a:off x="6674023" y="2211751"/>
-            <a:ext cx="294803" cy="294803"/>
-          </a:xfrm>
-          <a:prstGeom prst="rect">
-            <a:avLst/>
-          </a:prstGeom>
-        </p:spPr>
-      </p:pic>
-      <p:sp>
-        <p:nvSpPr>
-          <p:cNvPr id="12" name="Text 8"/>
-          <p:cNvSpPr/>
-          <p:nvPr/>
-        </p:nvSpPr>
-        <p:spPr>
-          <a:xfrm>
-            <a:off x="7315200" y="2057400"/>
-            <a:ext cx="4050792" cy="365760"/>
+          <a:ln w="9525">
+            <a:solidFill>
+              <a:srgbClr val="5A66A0"/>
+            </a:solidFill>
+            <a:prstDash val="solid"/>
+          </a:ln>
+        </p:spPr>
+      </p:sp>
+      <p:sp>
+        <p:nvSpPr>
+          <p:cNvPr id="19" name="Text 17"/>
+          <p:cNvSpPr/>
+          <p:nvPr/>
+        </p:nvSpPr>
+        <p:spPr>
+          <a:xfrm>
+            <a:off x="2487168" y="1874520"/>
+            <a:ext cx="1783080" cy="548640"/>
           </a:xfrm>
           <a:prstGeom prst="rect">
             <a:avLst/>
@@ -1362,11 +1521,11 @@
           <a:bodyPr wrap="square" lIns="0" tIns="0" rIns="0" bIns="0" rtlCol="0" anchor="ctr"/>
           <a:lstStyle/>
           <a:p>
-            <a:pPr indent="0" marL="0">
-              <a:buNone/>
-            </a:pPr>
-            <a:r>
-              <a:rPr lang="en-US" sz="1650" b="1" dirty="0">
+            <a:pPr algn="ctr" indent="0" marL="0">
+              <a:buNone/>
+            </a:pPr>
+            <a:r>
+              <a:rPr lang="en-US" sz="1250" b="1" dirty="0">
                 <a:solidFill>
                   <a:srgbClr val="FFFFFF"/>
                 </a:solidFill>
@@ -1374,46 +1533,7 @@
                 <a:ea typeface="Calibri" pitchFamily="34" charset="-122"/>
                 <a:cs typeface="Calibri" pitchFamily="34" charset="-120"/>
               </a:rPr>
-              <a:t>Manual, repetitive engineering</a:t>
-            </a:r>
-            <a:endParaRPr lang="en-US" sz="1650" dirty="0"/>
-          </a:p>
-        </p:txBody>
-      </p:sp>
-      <p:sp>
-        <p:nvSpPr>
-          <p:cNvPr id="13" name="Text 9"/>
-          <p:cNvSpPr/>
-          <p:nvPr/>
-        </p:nvSpPr>
-        <p:spPr>
-          <a:xfrm>
-            <a:off x="7315200" y="2459736"/>
-            <a:ext cx="4050792" cy="1051560"/>
-          </a:xfrm>
-          <a:prstGeom prst="rect">
-            <a:avLst/>
-          </a:prstGeom>
-          <a:noFill/>
-          <a:ln/>
-        </p:spPr>
-        <p:txBody>
-          <a:bodyPr wrap="square" lIns="0" tIns="0" rIns="0" bIns="0" rtlCol="0" anchor="t"/>
-          <a:lstStyle/>
-          <a:p>
-            <a:pPr indent="0" marL="0">
-              <a:buNone/>
-            </a:pPr>
-            <a:r>
-              <a:rPr lang="en-US" sz="1250" dirty="0">
-                <a:solidFill>
-                  <a:srgbClr val="CADCFC"/>
-                </a:solidFill>
-                <a:latin typeface="Calibri" pitchFamily="34" charset="0"/>
-                <a:ea typeface="Calibri" pitchFamily="34" charset="-122"/>
-                <a:cs typeface="Calibri" pitchFamily="34" charset="-120"/>
-              </a:rPr>
-              <a:t>Engineers stitch raw performance and configuration exports together in Excel; daily health checks, audits and reports are rebuilt by hand.</a:t>
+              <a:t>Huawei U2020</a:t>
             </a:r>
             <a:endParaRPr lang="en-US" sz="1250" dirty="0"/>
           </a:p>
@@ -1421,80 +1541,41 @@
       </p:sp>
       <p:sp>
         <p:nvSpPr>
-          <p:cNvPr id="14" name="Shape 10"/>
-          <p:cNvSpPr/>
-          <p:nvPr/>
-        </p:nvSpPr>
-        <p:spPr>
-          <a:xfrm>
-            <a:off x="548640" y="3840480"/>
-            <a:ext cx="5376672" cy="1847088"/>
+          <p:cNvPr id="20" name="Shape 18"/>
+          <p:cNvSpPr/>
+          <p:nvPr/>
+        </p:nvSpPr>
+        <p:spPr>
+          <a:xfrm>
+            <a:off x="4425696" y="1874520"/>
+            <a:ext cx="1783080" cy="548640"/>
           </a:xfrm>
           <a:prstGeom prst="roundRect">
             <a:avLst>
-              <a:gd name="adj" fmla="val 4455"/>
+              <a:gd name="adj" fmla="val 11667"/>
             </a:avLst>
           </a:prstGeom>
           <a:solidFill>
             <a:srgbClr val="2A3575"/>
           </a:solidFill>
-          <a:ln/>
-        </p:spPr>
-      </p:sp>
-      <p:sp>
-        <p:nvSpPr>
-          <p:cNvPr id="15" name="Shape 11"/>
-          <p:cNvSpPr/>
-          <p:nvPr/>
-        </p:nvSpPr>
-        <p:spPr>
-          <a:xfrm>
-            <a:off x="822960" y="4133088"/>
-            <a:ext cx="566928" cy="566928"/>
-          </a:xfrm>
-          <a:prstGeom prst="ellipse">
-            <a:avLst/>
-          </a:prstGeom>
-          <a:solidFill>
-            <a:srgbClr val="02C39A"/>
-          </a:solidFill>
-          <a:ln/>
-        </p:spPr>
-      </p:sp>
-      <p:pic>
-        <p:nvPicPr>
-          <p:cNvPr id="16" name="Image 2" descr="preencoded.png">    </p:cNvPr>
-          <p:cNvPicPr>
-            <a:picLocks noChangeAspect="1"/>
-          </p:cNvPicPr>
-          <p:nvPr/>
-        </p:nvPicPr>
-        <p:blipFill>
-          <a:blip r:embed="rId3"/>
-          <a:stretch>
-            <a:fillRect/>
-          </a:stretch>
-        </p:blipFill>
-        <p:spPr>
-          <a:xfrm>
-            <a:off x="959023" y="4269151"/>
-            <a:ext cx="294803" cy="294803"/>
-          </a:xfrm>
-          <a:prstGeom prst="rect">
-            <a:avLst/>
-          </a:prstGeom>
-        </p:spPr>
-      </p:pic>
-      <p:sp>
-        <p:nvSpPr>
-          <p:cNvPr id="17" name="Text 12"/>
-          <p:cNvSpPr/>
-          <p:nvPr/>
-        </p:nvSpPr>
-        <p:spPr>
-          <a:xfrm>
-            <a:off x="1600200" y="4114800"/>
-            <a:ext cx="4050792" cy="365760"/>
+          <a:ln w="9525">
+            <a:solidFill>
+              <a:srgbClr val="5A66A0"/>
+            </a:solidFill>
+            <a:prstDash val="solid"/>
+          </a:ln>
+        </p:spPr>
+      </p:sp>
+      <p:sp>
+        <p:nvSpPr>
+          <p:cNvPr id="21" name="Text 19"/>
+          <p:cNvSpPr/>
+          <p:nvPr/>
+        </p:nvSpPr>
+        <p:spPr>
+          <a:xfrm>
+            <a:off x="4425696" y="1874520"/>
+            <a:ext cx="1783080" cy="548640"/>
           </a:xfrm>
           <a:prstGeom prst="rect">
             <a:avLst/>
@@ -1506,11 +1587,11 @@
           <a:bodyPr wrap="square" lIns="0" tIns="0" rIns="0" bIns="0" rtlCol="0" anchor="ctr"/>
           <a:lstStyle/>
           <a:p>
-            <a:pPr indent="0" marL="0">
-              <a:buNone/>
-            </a:pPr>
-            <a:r>
-              <a:rPr lang="en-US" sz="1650" b="1" dirty="0">
+            <a:pPr algn="ctr" indent="0" marL="0">
+              <a:buNone/>
+            </a:pPr>
+            <a:r>
+              <a:rPr lang="en-US" sz="1250" b="1" dirty="0">
                 <a:solidFill>
                   <a:srgbClr val="FFFFFF"/>
                 </a:solidFill>
@@ -1518,46 +1599,7 @@
                 <a:ea typeface="Calibri" pitchFamily="34" charset="-122"/>
                 <a:cs typeface="Calibri" pitchFamily="34" charset="-120"/>
               </a:rPr>
-              <a:t>Reactive troubleshooting</a:t>
-            </a:r>
-            <a:endParaRPr lang="en-US" sz="1650" dirty="0"/>
-          </a:p>
-        </p:txBody>
-      </p:sp>
-      <p:sp>
-        <p:nvSpPr>
-          <p:cNvPr id="18" name="Text 13"/>
-          <p:cNvSpPr/>
-          <p:nvPr/>
-        </p:nvSpPr>
-        <p:spPr>
-          <a:xfrm>
-            <a:off x="1600200" y="4517136"/>
-            <a:ext cx="4050792" cy="1051560"/>
-          </a:xfrm>
-          <a:prstGeom prst="rect">
-            <a:avLst/>
-          </a:prstGeom>
-          <a:noFill/>
-          <a:ln/>
-        </p:spPr>
-        <p:txBody>
-          <a:bodyPr wrap="square" lIns="0" tIns="0" rIns="0" bIns="0" rtlCol="0" anchor="t"/>
-          <a:lstStyle/>
-          <a:p>
-            <a:pPr indent="0" marL="0">
-              <a:buNone/>
-            </a:pPr>
-            <a:r>
-              <a:rPr lang="en-US" sz="1250" dirty="0">
-                <a:solidFill>
-                  <a:srgbClr val="CADCFC"/>
-                </a:solidFill>
-                <a:latin typeface="Calibri" pitchFamily="34" charset="0"/>
-                <a:ea typeface="Calibri" pitchFamily="34" charset="-122"/>
-                <a:cs typeface="Calibri" pitchFamily="34" charset="-120"/>
-              </a:rPr>
-              <a:t>Sleeping cells, configuration drift and bad neighbor relations surface only after KPIs degrade — or after subscribers complain.</a:t>
+              <a:t>Nokia NetAct</a:t>
             </a:r>
             <a:endParaRPr lang="en-US" sz="1250" dirty="0"/>
           </a:p>
@@ -1565,80 +1607,80 @@
       </p:sp>
       <p:sp>
         <p:nvSpPr>
-          <p:cNvPr id="19" name="Shape 14"/>
-          <p:cNvSpPr/>
-          <p:nvPr/>
-        </p:nvSpPr>
-        <p:spPr>
-          <a:xfrm>
-            <a:off x="6263640" y="3840480"/>
-            <a:ext cx="5376672" cy="1847088"/>
+          <p:cNvPr id="22" name="Text 20"/>
+          <p:cNvSpPr/>
+          <p:nvPr/>
+        </p:nvSpPr>
+        <p:spPr>
+          <a:xfrm>
+            <a:off x="548640" y="2880360"/>
+            <a:ext cx="5660136" cy="274320"/>
+          </a:xfrm>
+          <a:prstGeom prst="rect">
+            <a:avLst/>
+          </a:prstGeom>
+          <a:noFill/>
+          <a:ln/>
+        </p:spPr>
+        <p:txBody>
+          <a:bodyPr wrap="square" lIns="0" tIns="0" rIns="0" bIns="0" rtlCol="0" anchor="ctr"/>
+          <a:lstStyle/>
+          <a:p>
+            <a:pPr algn="ctr" indent="0" marL="0">
+              <a:buNone/>
+            </a:pPr>
+            <a:r>
+              <a:rPr lang="en-US" sz="1050" i="1" dirty="0">
+                <a:solidFill>
+                  <a:srgbClr val="8A96C8"/>
+                </a:solidFill>
+                <a:latin typeface="Calibri" pitchFamily="34" charset="0"/>
+                <a:ea typeface="Calibri" pitchFamily="34" charset="-122"/>
+                <a:cs typeface="Calibri" pitchFamily="34" charset="-120"/>
+              </a:rPr>
+              <a:t>separate logins · separate formats · separate data</a:t>
+            </a:r>
+            <a:endParaRPr lang="en-US" sz="1050" dirty="0"/>
+          </a:p>
+        </p:txBody>
+      </p:sp>
+      <p:sp>
+        <p:nvSpPr>
+          <p:cNvPr id="23" name="Shape 21"/>
+          <p:cNvSpPr/>
+          <p:nvPr/>
+        </p:nvSpPr>
+        <p:spPr>
+          <a:xfrm>
+            <a:off x="548640" y="3703320"/>
+            <a:ext cx="1783080" cy="548640"/>
           </a:xfrm>
           <a:prstGeom prst="roundRect">
             <a:avLst>
-              <a:gd name="adj" fmla="val 4455"/>
+              <a:gd name="adj" fmla="val 11667"/>
             </a:avLst>
           </a:prstGeom>
           <a:solidFill>
             <a:srgbClr val="2A3575"/>
           </a:solidFill>
-          <a:ln/>
-        </p:spPr>
-      </p:sp>
-      <p:sp>
-        <p:nvSpPr>
-          <p:cNvPr id="20" name="Shape 15"/>
-          <p:cNvSpPr/>
-          <p:nvPr/>
-        </p:nvSpPr>
-        <p:spPr>
-          <a:xfrm>
-            <a:off x="6537960" y="4133088"/>
-            <a:ext cx="566928" cy="566928"/>
-          </a:xfrm>
-          <a:prstGeom prst="ellipse">
-            <a:avLst/>
-          </a:prstGeom>
-          <a:solidFill>
-            <a:srgbClr val="02C39A"/>
-          </a:solidFill>
-          <a:ln/>
-        </p:spPr>
-      </p:sp>
-      <p:pic>
-        <p:nvPicPr>
-          <p:cNvPr id="21" name="Image 3" descr="preencoded.png">    </p:cNvPr>
-          <p:cNvPicPr>
-            <a:picLocks noChangeAspect="1"/>
-          </p:cNvPicPr>
-          <p:nvPr/>
-        </p:nvPicPr>
-        <p:blipFill>
-          <a:blip r:embed="rId4"/>
-          <a:stretch>
-            <a:fillRect/>
-          </a:stretch>
-        </p:blipFill>
-        <p:spPr>
-          <a:xfrm>
-            <a:off x="6674023" y="4269151"/>
-            <a:ext cx="294803" cy="294803"/>
-          </a:xfrm>
-          <a:prstGeom prst="rect">
-            <a:avLst/>
-          </a:prstGeom>
-        </p:spPr>
-      </p:pic>
-      <p:sp>
-        <p:nvSpPr>
-          <p:cNvPr id="22" name="Text 16"/>
-          <p:cNvSpPr/>
-          <p:nvPr/>
-        </p:nvSpPr>
-        <p:spPr>
-          <a:xfrm>
-            <a:off x="7315200" y="4114800"/>
-            <a:ext cx="4050792" cy="365760"/>
+          <a:ln w="9525">
+            <a:solidFill>
+              <a:srgbClr val="5A66A0"/>
+            </a:solidFill>
+            <a:prstDash val="solid"/>
+          </a:ln>
+        </p:spPr>
+      </p:sp>
+      <p:sp>
+        <p:nvSpPr>
+          <p:cNvPr id="24" name="Text 22"/>
+          <p:cNvSpPr/>
+          <p:nvPr/>
+        </p:nvSpPr>
+        <p:spPr>
+          <a:xfrm>
+            <a:off x="548640" y="3703320"/>
+            <a:ext cx="1783080" cy="548640"/>
           </a:xfrm>
           <a:prstGeom prst="rect">
             <a:avLst/>
@@ -1650,11 +1692,321 @@
           <a:bodyPr wrap="square" lIns="0" tIns="0" rIns="0" bIns="0" rtlCol="0" anchor="ctr"/>
           <a:lstStyle/>
           <a:p>
+            <a:pPr algn="ctr" indent="0" marL="0">
+              <a:buNone/>
+            </a:pPr>
+            <a:r>
+              <a:rPr lang="en-US" sz="1250" dirty="0">
+                <a:solidFill>
+                  <a:srgbClr val="CADCFC"/>
+                </a:solidFill>
+                <a:latin typeface="Calibri" pitchFamily="34" charset="0"/>
+                <a:ea typeface="Calibri" pitchFamily="34" charset="-122"/>
+                <a:cs typeface="Calibri" pitchFamily="34" charset="-120"/>
+              </a:rPr>
+              <a:t>Radio team</a:t>
+            </a:r>
+            <a:endParaRPr lang="en-US" sz="1250" dirty="0"/>
+          </a:p>
+        </p:txBody>
+      </p:sp>
+      <p:sp>
+        <p:nvSpPr>
+          <p:cNvPr id="25" name="Shape 23"/>
+          <p:cNvSpPr/>
+          <p:nvPr/>
+        </p:nvSpPr>
+        <p:spPr>
+          <a:xfrm>
+            <a:off x="2487168" y="3703320"/>
+            <a:ext cx="1783080" cy="548640"/>
+          </a:xfrm>
+          <a:prstGeom prst="roundRect">
+            <a:avLst>
+              <a:gd name="adj" fmla="val 11667"/>
+            </a:avLst>
+          </a:prstGeom>
+          <a:solidFill>
+            <a:srgbClr val="2A3575"/>
+          </a:solidFill>
+          <a:ln w="9525">
+            <a:solidFill>
+              <a:srgbClr val="5A66A0"/>
+            </a:solidFill>
+            <a:prstDash val="solid"/>
+          </a:ln>
+        </p:spPr>
+      </p:sp>
+      <p:sp>
+        <p:nvSpPr>
+          <p:cNvPr id="26" name="Text 24"/>
+          <p:cNvSpPr/>
+          <p:nvPr/>
+        </p:nvSpPr>
+        <p:spPr>
+          <a:xfrm>
+            <a:off x="2487168" y="3703320"/>
+            <a:ext cx="1783080" cy="548640"/>
+          </a:xfrm>
+          <a:prstGeom prst="rect">
+            <a:avLst/>
+          </a:prstGeom>
+          <a:noFill/>
+          <a:ln/>
+        </p:spPr>
+        <p:txBody>
+          <a:bodyPr wrap="square" lIns="0" tIns="0" rIns="0" bIns="0" rtlCol="0" anchor="ctr"/>
+          <a:lstStyle/>
+          <a:p>
+            <a:pPr algn="ctr" indent="0" marL="0">
+              <a:buNone/>
+            </a:pPr>
+            <a:r>
+              <a:rPr lang="en-US" sz="1250" dirty="0">
+                <a:solidFill>
+                  <a:srgbClr val="CADCFC"/>
+                </a:solidFill>
+                <a:latin typeface="Calibri" pitchFamily="34" charset="0"/>
+                <a:ea typeface="Calibri" pitchFamily="34" charset="-122"/>
+                <a:cs typeface="Calibri" pitchFamily="34" charset="-120"/>
+              </a:rPr>
+              <a:t>Optimization team</a:t>
+            </a:r>
+            <a:endParaRPr lang="en-US" sz="1250" dirty="0"/>
+          </a:p>
+        </p:txBody>
+      </p:sp>
+      <p:sp>
+        <p:nvSpPr>
+          <p:cNvPr id="27" name="Shape 25"/>
+          <p:cNvSpPr/>
+          <p:nvPr/>
+        </p:nvSpPr>
+        <p:spPr>
+          <a:xfrm>
+            <a:off x="4425696" y="3703320"/>
+            <a:ext cx="1783080" cy="548640"/>
+          </a:xfrm>
+          <a:prstGeom prst="roundRect">
+            <a:avLst>
+              <a:gd name="adj" fmla="val 11667"/>
+            </a:avLst>
+          </a:prstGeom>
+          <a:solidFill>
+            <a:srgbClr val="2A3575"/>
+          </a:solidFill>
+          <a:ln w="9525">
+            <a:solidFill>
+              <a:srgbClr val="5A66A0"/>
+            </a:solidFill>
+            <a:prstDash val="solid"/>
+          </a:ln>
+        </p:spPr>
+      </p:sp>
+      <p:sp>
+        <p:nvSpPr>
+          <p:cNvPr id="28" name="Text 26"/>
+          <p:cNvSpPr/>
+          <p:nvPr/>
+        </p:nvSpPr>
+        <p:spPr>
+          <a:xfrm>
+            <a:off x="4425696" y="3703320"/>
+            <a:ext cx="1783080" cy="548640"/>
+          </a:xfrm>
+          <a:prstGeom prst="rect">
+            <a:avLst/>
+          </a:prstGeom>
+          <a:noFill/>
+          <a:ln/>
+        </p:spPr>
+        <p:txBody>
+          <a:bodyPr wrap="square" lIns="0" tIns="0" rIns="0" bIns="0" rtlCol="0" anchor="ctr"/>
+          <a:lstStyle/>
+          <a:p>
+            <a:pPr algn="ctr" indent="0" marL="0">
+              <a:buNone/>
+            </a:pPr>
+            <a:r>
+              <a:rPr lang="en-US" sz="1250" dirty="0">
+                <a:solidFill>
+                  <a:srgbClr val="CADCFC"/>
+                </a:solidFill>
+                <a:latin typeface="Calibri" pitchFamily="34" charset="0"/>
+                <a:ea typeface="Calibri" pitchFamily="34" charset="-122"/>
+                <a:cs typeface="Calibri" pitchFamily="34" charset="-120"/>
+              </a:rPr>
+              <a:t>NOC team</a:t>
+            </a:r>
+            <a:endParaRPr lang="en-US" sz="1250" dirty="0"/>
+          </a:p>
+        </p:txBody>
+      </p:sp>
+      <p:sp>
+        <p:nvSpPr>
+          <p:cNvPr id="29" name="Shape 27"/>
+          <p:cNvSpPr/>
+          <p:nvPr/>
+        </p:nvSpPr>
+        <p:spPr>
+          <a:xfrm>
+            <a:off x="2487168" y="5074920"/>
+            <a:ext cx="1783080" cy="548640"/>
+          </a:xfrm>
+          <a:prstGeom prst="roundRect">
+            <a:avLst>
+              <a:gd name="adj" fmla="val 11667"/>
+            </a:avLst>
+          </a:prstGeom>
+          <a:solidFill>
+            <a:srgbClr val="F96167"/>
+          </a:solidFill>
+          <a:ln/>
+        </p:spPr>
+      </p:sp>
+      <p:sp>
+        <p:nvSpPr>
+          <p:cNvPr id="30" name="Text 28"/>
+          <p:cNvSpPr/>
+          <p:nvPr/>
+        </p:nvSpPr>
+        <p:spPr>
+          <a:xfrm>
+            <a:off x="2487168" y="5074920"/>
+            <a:ext cx="1783080" cy="548640"/>
+          </a:xfrm>
+          <a:prstGeom prst="rect">
+            <a:avLst/>
+          </a:prstGeom>
+          <a:noFill/>
+          <a:ln/>
+        </p:spPr>
+        <p:txBody>
+          <a:bodyPr wrap="square" lIns="0" tIns="0" rIns="0" bIns="0" rtlCol="0" anchor="ctr"/>
+          <a:lstStyle/>
+          <a:p>
+            <a:pPr algn="ctr" indent="0" marL="0">
+              <a:buNone/>
+            </a:pPr>
+            <a:r>
+              <a:rPr lang="en-US" sz="1300" b="1" spc="200" kern="0" dirty="0">
+                <a:solidFill>
+                  <a:srgbClr val="1E2761"/>
+                </a:solidFill>
+                <a:latin typeface="Calibri" pitchFamily="34" charset="0"/>
+                <a:ea typeface="Calibri" pitchFamily="34" charset="-122"/>
+                <a:cs typeface="Calibri" pitchFamily="34" charset="-120"/>
+              </a:rPr>
+              <a:t>BOTTLENECK</a:t>
+            </a:r>
+            <a:endParaRPr lang="en-US" sz="1300" dirty="0"/>
+          </a:p>
+        </p:txBody>
+      </p:sp>
+      <p:sp>
+        <p:nvSpPr>
+          <p:cNvPr id="31" name="Text 29"/>
+          <p:cNvSpPr/>
+          <p:nvPr/>
+        </p:nvSpPr>
+        <p:spPr>
+          <a:xfrm>
+            <a:off x="548640" y="5733288"/>
+            <a:ext cx="5660136" cy="274320"/>
+          </a:xfrm>
+          <a:prstGeom prst="rect">
+            <a:avLst/>
+          </a:prstGeom>
+          <a:noFill/>
+          <a:ln/>
+        </p:spPr>
+        <p:txBody>
+          <a:bodyPr wrap="square" lIns="0" tIns="0" rIns="0" bIns="0" rtlCol="0" anchor="ctr"/>
+          <a:lstStyle/>
+          <a:p>
+            <a:pPr algn="ctr" indent="0" marL="0">
+              <a:buNone/>
+            </a:pPr>
+            <a:r>
+              <a:rPr lang="en-US" sz="1100" i="1" dirty="0">
+                <a:solidFill>
+                  <a:srgbClr val="F96167"/>
+                </a:solidFill>
+                <a:latin typeface="Calibri" pitchFamily="34" charset="0"/>
+                <a:ea typeface="Calibri" pitchFamily="34" charset="-122"/>
+                <a:cs typeface="Calibri" pitchFamily="34" charset="-120"/>
+              </a:rPr>
+              <a:t>delayed optimization · duplicated effort · rising OpEx</a:t>
+            </a:r>
+            <a:endParaRPr lang="en-US" sz="1100" dirty="0"/>
+          </a:p>
+        </p:txBody>
+      </p:sp>
+      <p:sp>
+        <p:nvSpPr>
+          <p:cNvPr id="32" name="Text 30"/>
+          <p:cNvSpPr/>
+          <p:nvPr/>
+        </p:nvSpPr>
+        <p:spPr>
+          <a:xfrm>
+            <a:off x="6903720" y="1783080"/>
+            <a:ext cx="4736592" cy="868680"/>
+          </a:xfrm>
+          <a:prstGeom prst="rect">
+            <a:avLst/>
+          </a:prstGeom>
+          <a:noFill/>
+          <a:ln/>
+        </p:spPr>
+        <p:txBody>
+          <a:bodyPr wrap="square" lIns="0" tIns="0" rIns="0" bIns="0" rtlCol="0" anchor="ctr"/>
+          <a:lstStyle/>
+          <a:p>
             <a:pPr indent="0" marL="0">
               <a:buNone/>
             </a:pPr>
             <a:r>
-              <a:rPr lang="en-US" sz="1650" b="1" dirty="0">
+              <a:rPr lang="en-US" sz="6000" b="1" dirty="0">
+                <a:solidFill>
+                  <a:srgbClr val="02C39A"/>
+                </a:solidFill>
+                <a:latin typeface="Calibri" pitchFamily="34" charset="0"/>
+                <a:ea typeface="Calibri" pitchFamily="34" charset="-122"/>
+                <a:cs typeface="Calibri" pitchFamily="34" charset="-120"/>
+              </a:rPr>
+              <a:t>40%</a:t>
+            </a:r>
+            <a:endParaRPr lang="en-US" sz="6000" dirty="0"/>
+          </a:p>
+        </p:txBody>
+      </p:sp>
+      <p:sp>
+        <p:nvSpPr>
+          <p:cNvPr id="33" name="Text 31"/>
+          <p:cNvSpPr/>
+          <p:nvPr/>
+        </p:nvSpPr>
+        <p:spPr>
+          <a:xfrm>
+            <a:off x="6903720" y="2697480"/>
+            <a:ext cx="4736592" cy="685800"/>
+          </a:xfrm>
+          <a:prstGeom prst="rect">
+            <a:avLst/>
+          </a:prstGeom>
+          <a:noFill/>
+          <a:ln/>
+        </p:spPr>
+        <p:txBody>
+          <a:bodyPr wrap="square" lIns="0" tIns="0" rIns="0" bIns="0" rtlCol="0" anchor="t"/>
+          <a:lstStyle/>
+          <a:p>
+            <a:pPr indent="0" marL="0">
+              <a:buNone/>
+            </a:pPr>
+            <a:r>
+              <a:rPr lang="en-US" sz="1350" dirty="0">
                 <a:solidFill>
                   <a:srgbClr val="FFFFFF"/>
                 </a:solidFill>
@@ -1662,22 +2014,22 @@
                 <a:ea typeface="Calibri" pitchFamily="34" charset="-122"/>
                 <a:cs typeface="Calibri" pitchFamily="34" charset="-120"/>
               </a:rPr>
-              <a:t>Costly, closed tooling</a:t>
-            </a:r>
-            <a:endParaRPr lang="en-US" sz="1650" dirty="0"/>
-          </a:p>
-        </p:txBody>
-      </p:sp>
-      <p:sp>
-        <p:nvSpPr>
-          <p:cNvPr id="23" name="Text 17"/>
-          <p:cNvSpPr/>
-          <p:nvPr/>
-        </p:nvSpPr>
-        <p:spPr>
-          <a:xfrm>
-            <a:off x="7315200" y="4517136"/>
-            <a:ext cx="4050792" cy="1051560"/>
+              <a:t>of an engineer's day is spent logging into separate, incompatible vendor platforms.</a:t>
+            </a:r>
+            <a:endParaRPr lang="en-US" sz="1350" dirty="0"/>
+          </a:p>
+        </p:txBody>
+      </p:sp>
+      <p:sp>
+        <p:nvSpPr>
+          <p:cNvPr id="34" name="Text 32"/>
+          <p:cNvSpPr/>
+          <p:nvPr/>
+        </p:nvSpPr>
+        <p:spPr>
+          <a:xfrm>
+            <a:off x="6903720" y="3611880"/>
+            <a:ext cx="4736592" cy="1920240"/>
           </a:xfrm>
           <a:prstGeom prst="rect">
             <a:avLst/>
@@ -1693,7 +2045,7 @@
               <a:buNone/>
             </a:pPr>
             <a:r>
-              <a:rPr lang="en-US" sz="1250" dirty="0">
+              <a:rPr lang="en-US" sz="1300" dirty="0">
                 <a:solidFill>
                   <a:srgbClr val="CADCFC"/>
                 </a:solidFill>
@@ -1701,22 +2053,22 @@
                 <a:ea typeface="Calibri" pitchFamily="34" charset="-122"/>
                 <a:cs typeface="Calibri" pitchFamily="34" charset="-120"/>
               </a:rPr>
-              <a:t>Commercial network-analytics suites are licensed per seat and per vendor, and cannot be tailored to our own processes.</a:t>
-            </a:r>
-            <a:endParaRPr lang="en-US" sz="1250" dirty="0"/>
-          </a:p>
-        </p:txBody>
-      </p:sp>
-      <p:sp>
-        <p:nvSpPr>
-          <p:cNvPr id="24" name="Text 18"/>
-          <p:cNvSpPr/>
-          <p:nvPr/>
-        </p:nvSpPr>
-        <p:spPr>
-          <a:xfrm>
-            <a:off x="548640" y="5989320"/>
-            <a:ext cx="11064240" cy="411480"/>
+              <a:t>Our telecom engineering department is drowning in vendor-specific silos. Managing a multi-vendor, multi-RAT network today means separate tools, separate data and separate workflows for every vendor and every technology — fragmentation that delays network optimization and spikes operational costs.</a:t>
+            </a:r>
+            <a:endParaRPr lang="en-US" sz="1300" dirty="0"/>
+          </a:p>
+        </p:txBody>
+      </p:sp>
+      <p:sp>
+        <p:nvSpPr>
+          <p:cNvPr id="35" name="Text 33"/>
+          <p:cNvSpPr/>
+          <p:nvPr/>
+        </p:nvSpPr>
+        <p:spPr>
+          <a:xfrm>
+            <a:off x="548640" y="6355080"/>
+            <a:ext cx="11064240" cy="274320"/>
           </a:xfrm>
           <a:prstGeom prst="rect">
             <a:avLst/>
@@ -1732,17 +2084,17 @@
               <a:buNone/>
             </a:pPr>
             <a:r>
-              <a:rPr lang="en-US" sz="1450" i="1" dirty="0">
-                <a:solidFill>
-                  <a:srgbClr val="CADCFC"/>
-                </a:solidFill>
-                <a:latin typeface="Calibri" pitchFamily="34" charset="0"/>
-                <a:ea typeface="Calibri" pitchFamily="34" charset="-122"/>
-                <a:cs typeface="Calibri" pitchFamily="34" charset="-120"/>
-              </a:rPr>
-              <a:t>The result: slow decisions, lost engineering hours, and network issues discovered late.</a:t>
-            </a:r>
-            <a:endParaRPr lang="en-US" sz="1450" dirty="0"/>
+              <a:rPr lang="en-US" sz="900" dirty="0">
+                <a:solidFill>
+                  <a:srgbClr val="8A96C8"/>
+                </a:solidFill>
+                <a:latin typeface="Calibri" pitchFamily="34" charset="0"/>
+                <a:ea typeface="Calibri" pitchFamily="34" charset="-122"/>
+                <a:cs typeface="Calibri" pitchFamily="34" charset="-120"/>
+              </a:rPr>
+              <a:t>Source: FNT Software — “The Challenge of Fragmented Systems: A Roadblock to Telecom Agility”</a:t>
+            </a:r>
+            <a:endParaRPr lang="en-US" sz="900" dirty="0"/>
           </a:p>
         </p:txBody>
       </p:sp>
@@ -1787,7 +2139,7 @@
         <p:spPr>
           <a:xfrm>
             <a:off x="548640" y="384048"/>
-            <a:ext cx="5486400" cy="320040"/>
+            <a:ext cx="8229600" cy="320040"/>
           </a:xfrm>
           <a:prstGeom prst="rect">
             <a:avLst/>
@@ -1811,7 +2163,7 @@
                 <a:ea typeface="Calibri" pitchFamily="34" charset="-122"/>
                 <a:cs typeface="Calibri" pitchFamily="34" charset="-120"/>
               </a:rPr>
-              <a:t>THE SOLUTION</a:t>
+              <a:t>THE SOLUTION — PRIMENET UNIFIED INTERFACE</a:t>
             </a:r>
             <a:endParaRPr lang="en-US" sz="1300" dirty="0"/>
           </a:p>
@@ -1826,7 +2178,7 @@
         <p:spPr>
           <a:xfrm>
             <a:off x="548640" y="713232"/>
-            <a:ext cx="11064240" cy="731520"/>
+            <a:ext cx="11064240" cy="685800"/>
           </a:xfrm>
           <a:prstGeom prst="rect">
             <a:avLst/>
@@ -1850,7 +2202,7 @@
                 <a:ea typeface="Calibri" pitchFamily="34" charset="-122"/>
                 <a:cs typeface="Calibri" pitchFamily="34" charset="-120"/>
               </a:rPr>
-              <a:t>PrimeNet — One Platform for the Whole Network</a:t>
+              <a:t>PrimeNet: One Interface, Every Network</a:t>
             </a:r>
             <a:endParaRPr lang="en-US" sz="3600" dirty="0"/>
           </a:p>
@@ -1864,12 +2216,12 @@
         </p:nvSpPr>
         <p:spPr>
           <a:xfrm>
-            <a:off x="548640" y="1783080"/>
-            <a:ext cx="4892040" cy="841248"/>
+            <a:off x="658368" y="1920240"/>
+            <a:ext cx="3200400" cy="1600200"/>
           </a:xfrm>
           <a:prstGeom prst="roundRect">
             <a:avLst>
-              <a:gd name="adj" fmla="val 8696"/>
+              <a:gd name="adj" fmla="val 5143"/>
             </a:avLst>
           </a:prstGeom>
           <a:solidFill>
@@ -1891,8 +2243,8 @@
         </p:nvSpPr>
         <p:spPr>
           <a:xfrm>
-            <a:off x="822960" y="1783080"/>
-            <a:ext cx="4434840" cy="841248"/>
+            <a:off x="932688" y="2121408"/>
+            <a:ext cx="2651760" cy="274320"/>
           </a:xfrm>
           <a:prstGeom prst="rect">
             <a:avLst/>
@@ -1908,7 +2260,46 @@
               <a:buNone/>
             </a:pPr>
             <a:r>
-              <a:rPr lang="en-US" sz="1350" b="1" dirty="0">
+              <a:rPr lang="en-US" sz="1150" b="1" spc="200" kern="0" dirty="0">
+                <a:solidFill>
+                  <a:srgbClr val="029B7B"/>
+                </a:solidFill>
+                <a:latin typeface="Calibri" pitchFamily="34" charset="0"/>
+                <a:ea typeface="Calibri" pitchFamily="34" charset="-122"/>
+                <a:cs typeface="Calibri" pitchFamily="34" charset="-120"/>
+              </a:rPr>
+              <a:t>1 · INPUT</a:t>
+            </a:r>
+            <a:endParaRPr lang="en-US" sz="1150" dirty="0"/>
+          </a:p>
+        </p:txBody>
+      </p:sp>
+      <p:sp>
+        <p:nvSpPr>
+          <p:cNvPr id="6" name="Text 4"/>
+          <p:cNvSpPr/>
+          <p:nvPr/>
+        </p:nvSpPr>
+        <p:spPr>
+          <a:xfrm>
+            <a:off x="932688" y="2395728"/>
+            <a:ext cx="2651760" cy="566928"/>
+          </a:xfrm>
+          <a:prstGeom prst="rect">
+            <a:avLst/>
+          </a:prstGeom>
+          <a:noFill/>
+          <a:ln/>
+        </p:spPr>
+        <p:txBody>
+          <a:bodyPr wrap="square" lIns="0" tIns="0" rIns="0" bIns="0" rtlCol="0" anchor="t"/>
+          <a:lstStyle/>
+          <a:p>
+            <a:pPr indent="0" marL="0">
+              <a:buNone/>
+            </a:pPr>
+            <a:r>
+              <a:rPr lang="en-US" sz="1550" b="1" dirty="0">
                 <a:solidFill>
                   <a:srgbClr val="1E2761"/>
                 </a:solidFill>
@@ -1916,13 +2307,38 @@
                 <a:ea typeface="Calibri" pitchFamily="34" charset="-122"/>
                 <a:cs typeface="Calibri" pitchFamily="34" charset="-120"/>
               </a:rPr>
-              <a:t>Live network</a:t>
-            </a:r>
+              <a:t>Multi-vendor, multi-RAT data</a:t>
+            </a:r>
+            <a:endParaRPr lang="en-US" sz="1550" dirty="0"/>
+          </a:p>
+        </p:txBody>
+      </p:sp>
+      <p:sp>
+        <p:nvSpPr>
+          <p:cNvPr id="7" name="Text 5"/>
+          <p:cNvSpPr/>
+          <p:nvPr/>
+        </p:nvSpPr>
+        <p:spPr>
+          <a:xfrm>
+            <a:off x="932688" y="2907792"/>
+            <a:ext cx="2651760" cy="548640"/>
+          </a:xfrm>
+          <a:prstGeom prst="rect">
+            <a:avLst/>
+          </a:prstGeom>
+          <a:noFill/>
+          <a:ln/>
+        </p:spPr>
+        <p:txBody>
+          <a:bodyPr wrap="square" lIns="0" tIns="0" rIns="0" bIns="0" rtlCol="0" anchor="t"/>
+          <a:lstStyle/>
+          <a:p>
             <a:pPr indent="0" marL="0">
               <a:buNone/>
             </a:pPr>
             <a:r>
-              <a:rPr lang="en-US" sz="1350" dirty="0">
+              <a:rPr lang="en-US" sz="1150" dirty="0">
                 <a:solidFill>
                   <a:srgbClr val="44546A"/>
                 </a:solidFill>
@@ -1930,54 +2346,173 @@
                 <a:ea typeface="Calibri" pitchFamily="34" charset="-122"/>
                 <a:cs typeface="Calibri" pitchFamily="34" charset="-120"/>
               </a:rPr>
-              <a:t>  —  Nokia + Huawei, 2G–5G</a:t>
-            </a:r>
-            <a:endParaRPr lang="en-US" sz="1350" dirty="0"/>
-          </a:p>
-        </p:txBody>
-      </p:sp>
-      <p:sp>
-        <p:nvSpPr>
-          <p:cNvPr id="6" name="Shape 4"/>
-          <p:cNvSpPr/>
-          <p:nvPr/>
-        </p:nvSpPr>
-        <p:spPr>
-          <a:xfrm flipV="1">
-            <a:off x="2894076" y="2692908"/>
-            <a:ext cx="201168" cy="173736"/>
-          </a:xfrm>
-          <a:prstGeom prst="triangle">
-            <a:avLst/>
-          </a:prstGeom>
-          <a:solidFill>
-            <a:srgbClr val="02C39A"/>
-          </a:solidFill>
-          <a:ln/>
-        </p:spPr>
-      </p:sp>
-      <p:sp>
-        <p:nvSpPr>
-          <p:cNvPr id="7" name="Shape 5"/>
-          <p:cNvSpPr/>
-          <p:nvPr/>
-        </p:nvSpPr>
-        <p:spPr>
-          <a:xfrm>
-            <a:off x="548640" y="2944368"/>
-            <a:ext cx="4892040" cy="841248"/>
+              <a:t>Ericsson · Huawei · Nokia — 2G to 5G, performance &amp; configuration</a:t>
+            </a:r>
+            <a:endParaRPr lang="en-US" sz="1150" dirty="0"/>
+          </a:p>
+        </p:txBody>
+      </p:sp>
+      <p:sp>
+        <p:nvSpPr>
+          <p:cNvPr id="8" name="Shape 6"/>
+          <p:cNvSpPr/>
+          <p:nvPr/>
+        </p:nvSpPr>
+        <p:spPr>
+          <a:xfrm>
+            <a:off x="4498848" y="1920240"/>
+            <a:ext cx="3200400" cy="1600200"/>
           </a:xfrm>
           <a:prstGeom prst="roundRect">
             <a:avLst>
-              <a:gd name="adj" fmla="val 8696"/>
+              <a:gd name="adj" fmla="val 5143"/>
             </a:avLst>
           </a:prstGeom>
           <a:solidFill>
-            <a:srgbClr val="F0F4FC"/>
+            <a:srgbClr val="1E2761"/>
+          </a:solidFill>
+          <a:ln/>
+        </p:spPr>
+      </p:sp>
+      <p:sp>
+        <p:nvSpPr>
+          <p:cNvPr id="9" name="Text 7"/>
+          <p:cNvSpPr/>
+          <p:nvPr/>
+        </p:nvSpPr>
+        <p:spPr>
+          <a:xfrm>
+            <a:off x="4773168" y="2121408"/>
+            <a:ext cx="2651760" cy="274320"/>
+          </a:xfrm>
+          <a:prstGeom prst="rect">
+            <a:avLst/>
+          </a:prstGeom>
+          <a:noFill/>
+          <a:ln/>
+        </p:spPr>
+        <p:txBody>
+          <a:bodyPr wrap="square" lIns="0" tIns="0" rIns="0" bIns="0" rtlCol="0" anchor="ctr"/>
+          <a:lstStyle/>
+          <a:p>
+            <a:pPr indent="0" marL="0">
+              <a:buNone/>
+            </a:pPr>
+            <a:r>
+              <a:rPr lang="en-US" sz="1150" b="1" spc="200" kern="0" dirty="0">
+                <a:solidFill>
+                  <a:srgbClr val="02C39A"/>
+                </a:solidFill>
+                <a:latin typeface="Calibri" pitchFamily="34" charset="0"/>
+                <a:ea typeface="Calibri" pitchFamily="34" charset="-122"/>
+                <a:cs typeface="Calibri" pitchFamily="34" charset="-120"/>
+              </a:rPr>
+              <a:t>2 · CORE</a:t>
+            </a:r>
+            <a:endParaRPr lang="en-US" sz="1150" dirty="0"/>
+          </a:p>
+        </p:txBody>
+      </p:sp>
+      <p:sp>
+        <p:nvSpPr>
+          <p:cNvPr id="10" name="Text 8"/>
+          <p:cNvSpPr/>
+          <p:nvPr/>
+        </p:nvSpPr>
+        <p:spPr>
+          <a:xfrm>
+            <a:off x="4773168" y="2395728"/>
+            <a:ext cx="2651760" cy="566928"/>
+          </a:xfrm>
+          <a:prstGeom prst="rect">
+            <a:avLst/>
+          </a:prstGeom>
+          <a:noFill/>
+          <a:ln/>
+        </p:spPr>
+        <p:txBody>
+          <a:bodyPr wrap="square" lIns="0" tIns="0" rIns="0" bIns="0" rtlCol="0" anchor="t"/>
+          <a:lstStyle/>
+          <a:p>
+            <a:pPr indent="0" marL="0">
+              <a:buNone/>
+            </a:pPr>
+            <a:r>
+              <a:rPr lang="en-US" sz="1550" b="1" dirty="0">
+                <a:solidFill>
+                  <a:srgbClr val="FFFFFF"/>
+                </a:solidFill>
+                <a:latin typeface="Calibri" pitchFamily="34" charset="0"/>
+                <a:ea typeface="Calibri" pitchFamily="34" charset="-122"/>
+                <a:cs typeface="Calibri" pitchFamily="34" charset="-120"/>
+              </a:rPr>
+              <a:t>PrimeNet Engine</a:t>
+            </a:r>
+            <a:endParaRPr lang="en-US" sz="1550" dirty="0"/>
+          </a:p>
+        </p:txBody>
+      </p:sp>
+      <p:sp>
+        <p:nvSpPr>
+          <p:cNvPr id="11" name="Text 9"/>
+          <p:cNvSpPr/>
+          <p:nvPr/>
+        </p:nvSpPr>
+        <p:spPr>
+          <a:xfrm>
+            <a:off x="4773168" y="2907792"/>
+            <a:ext cx="2651760" cy="548640"/>
+          </a:xfrm>
+          <a:prstGeom prst="rect">
+            <a:avLst/>
+          </a:prstGeom>
+          <a:noFill/>
+          <a:ln/>
+        </p:spPr>
+        <p:txBody>
+          <a:bodyPr wrap="square" lIns="0" tIns="0" rIns="0" bIns="0" rtlCol="0" anchor="t"/>
+          <a:lstStyle/>
+          <a:p>
+            <a:pPr indent="0" marL="0">
+              <a:buNone/>
+            </a:pPr>
+            <a:r>
+              <a:rPr lang="en-US" sz="1150" dirty="0">
+                <a:solidFill>
+                  <a:srgbClr val="CADCFC"/>
+                </a:solidFill>
+                <a:latin typeface="Calibri" pitchFamily="34" charset="0"/>
+                <a:ea typeface="Calibri" pitchFamily="34" charset="-122"/>
+                <a:cs typeface="Calibri" pitchFamily="34" charset="-120"/>
+              </a:rPr>
+              <a:t>unifies, normalizes and analyzes every source in one data model</a:t>
+            </a:r>
+            <a:endParaRPr lang="en-US" sz="1150" dirty="0"/>
+          </a:p>
+        </p:txBody>
+      </p:sp>
+      <p:sp>
+        <p:nvSpPr>
+          <p:cNvPr id="12" name="Shape 10"/>
+          <p:cNvSpPr/>
+          <p:nvPr/>
+        </p:nvSpPr>
+        <p:spPr>
+          <a:xfrm>
+            <a:off x="8339328" y="1920240"/>
+            <a:ext cx="3200400" cy="1600200"/>
+          </a:xfrm>
+          <a:prstGeom prst="roundRect">
+            <a:avLst>
+              <a:gd name="adj" fmla="val 5143"/>
+            </a:avLst>
+          </a:prstGeom>
+          <a:solidFill>
+            <a:srgbClr val="DDF6F0"/>
           </a:solidFill>
           <a:ln w="12700">
             <a:solidFill>
-              <a:srgbClr val="CADCFC"/>
+              <a:srgbClr val="02C39A"/>
             </a:solidFill>
             <a:prstDash val="solid"/>
           </a:ln>
@@ -1985,14 +2520,14 @@
       </p:sp>
       <p:sp>
         <p:nvSpPr>
-          <p:cNvPr id="8" name="Text 6"/>
-          <p:cNvSpPr/>
-          <p:nvPr/>
-        </p:nvSpPr>
-        <p:spPr>
-          <a:xfrm>
-            <a:off x="822960" y="2944368"/>
-            <a:ext cx="4434840" cy="841248"/>
+          <p:cNvPr id="13" name="Text 11"/>
+          <p:cNvSpPr/>
+          <p:nvPr/>
+        </p:nvSpPr>
+        <p:spPr>
+          <a:xfrm>
+            <a:off x="8613648" y="2121408"/>
+            <a:ext cx="2651760" cy="274320"/>
           </a:xfrm>
           <a:prstGeom prst="rect">
             <a:avLst/>
@@ -2008,7 +2543,46 @@
               <a:buNone/>
             </a:pPr>
             <a:r>
-              <a:rPr lang="en-US" sz="1350" b="1" dirty="0">
+              <a:rPr lang="en-US" sz="1150" b="1" spc="200" kern="0" dirty="0">
+                <a:solidFill>
+                  <a:srgbClr val="029B7B"/>
+                </a:solidFill>
+                <a:latin typeface="Calibri" pitchFamily="34" charset="0"/>
+                <a:ea typeface="Calibri" pitchFamily="34" charset="-122"/>
+                <a:cs typeface="Calibri" pitchFamily="34" charset="-120"/>
+              </a:rPr>
+              <a:t>3 · OUTPUT</a:t>
+            </a:r>
+            <a:endParaRPr lang="en-US" sz="1150" dirty="0"/>
+          </a:p>
+        </p:txBody>
+      </p:sp>
+      <p:sp>
+        <p:nvSpPr>
+          <p:cNvPr id="14" name="Text 12"/>
+          <p:cNvSpPr/>
+          <p:nvPr/>
+        </p:nvSpPr>
+        <p:spPr>
+          <a:xfrm>
+            <a:off x="8613648" y="2395728"/>
+            <a:ext cx="2651760" cy="566928"/>
+          </a:xfrm>
+          <a:prstGeom prst="rect">
+            <a:avLst/>
+          </a:prstGeom>
+          <a:noFill/>
+          <a:ln/>
+        </p:spPr>
+        <p:txBody>
+          <a:bodyPr wrap="square" lIns="0" tIns="0" rIns="0" bIns="0" rtlCol="0" anchor="t"/>
+          <a:lstStyle/>
+          <a:p>
+            <a:pPr indent="0" marL="0">
+              <a:buNone/>
+            </a:pPr>
+            <a:r>
+              <a:rPr lang="en-US" sz="1550" b="1" dirty="0">
                 <a:solidFill>
                   <a:srgbClr val="1E2761"/>
                 </a:solidFill>
@@ -2016,13 +2590,38 @@
                 <a:ea typeface="Calibri" pitchFamily="34" charset="-122"/>
                 <a:cs typeface="Calibri" pitchFamily="34" charset="-120"/>
               </a:rPr>
-              <a:t>Automated pipeline</a:t>
-            </a:r>
+              <a:t>Unified web interface</a:t>
+            </a:r>
+            <a:endParaRPr lang="en-US" sz="1550" dirty="0"/>
+          </a:p>
+        </p:txBody>
+      </p:sp>
+      <p:sp>
+        <p:nvSpPr>
+          <p:cNvPr id="15" name="Text 13"/>
+          <p:cNvSpPr/>
+          <p:nvPr/>
+        </p:nvSpPr>
+        <p:spPr>
+          <a:xfrm>
+            <a:off x="8613648" y="2907792"/>
+            <a:ext cx="2651760" cy="548640"/>
+          </a:xfrm>
+          <a:prstGeom prst="rect">
+            <a:avLst/>
+          </a:prstGeom>
+          <a:noFill/>
+          <a:ln/>
+        </p:spPr>
+        <p:txBody>
+          <a:bodyPr wrap="square" lIns="0" tIns="0" rIns="0" bIns="0" rtlCol="0" anchor="t"/>
+          <a:lstStyle/>
+          <a:p>
             <a:pPr indent="0" marL="0">
               <a:buNone/>
             </a:pPr>
             <a:r>
-              <a:rPr lang="en-US" sz="1350" dirty="0">
+              <a:rPr lang="en-US" sz="1150" dirty="0">
                 <a:solidFill>
                   <a:srgbClr val="44546A"/>
                 </a:solidFill>
@@ -2030,22 +2629,22 @@
                 <a:ea typeface="Calibri" pitchFamily="34" charset="-122"/>
                 <a:cs typeface="Calibri" pitchFamily="34" charset="-120"/>
               </a:rPr>
-              <a:t>  —  hourly &amp; daily collection</a:t>
-            </a:r>
-            <a:endParaRPr lang="en-US" sz="1350" dirty="0"/>
-          </a:p>
-        </p:txBody>
-      </p:sp>
-      <p:sp>
-        <p:nvSpPr>
-          <p:cNvPr id="9" name="Shape 7"/>
-          <p:cNvSpPr/>
-          <p:nvPr/>
-        </p:nvSpPr>
-        <p:spPr>
-          <a:xfrm flipV="1">
-            <a:off x="2894076" y="3854196"/>
-            <a:ext cx="201168" cy="173736"/>
+              <a:t>one dashboard for every team, regardless of hardware provider</a:t>
+            </a:r>
+            <a:endParaRPr lang="en-US" sz="1150" dirty="0"/>
+          </a:p>
+        </p:txBody>
+      </p:sp>
+      <p:sp>
+        <p:nvSpPr>
+          <p:cNvPr id="16" name="Shape 14"/>
+          <p:cNvSpPr/>
+          <p:nvPr/>
+        </p:nvSpPr>
+        <p:spPr>
+          <a:xfrm rot="5400000">
+            <a:off x="3968496" y="2546604"/>
+            <a:ext cx="384048" cy="347472"/>
           </a:xfrm>
           <a:prstGeom prst="triangle">
             <a:avLst/>
@@ -2058,94 +2657,14 @@
       </p:sp>
       <p:sp>
         <p:nvSpPr>
-          <p:cNvPr id="10" name="Shape 8"/>
-          <p:cNvSpPr/>
-          <p:nvPr/>
-        </p:nvSpPr>
-        <p:spPr>
-          <a:xfrm>
-            <a:off x="548640" y="4105656"/>
-            <a:ext cx="4892040" cy="841248"/>
-          </a:xfrm>
-          <a:prstGeom prst="roundRect">
-            <a:avLst>
-              <a:gd name="adj" fmla="val 8696"/>
-            </a:avLst>
-          </a:prstGeom>
-          <a:solidFill>
-            <a:srgbClr val="F0F4FC"/>
-          </a:solidFill>
-          <a:ln w="12700">
-            <a:solidFill>
-              <a:srgbClr val="CADCFC"/>
-            </a:solidFill>
-            <a:prstDash val="solid"/>
-          </a:ln>
-        </p:spPr>
-      </p:sp>
-      <p:sp>
-        <p:nvSpPr>
-          <p:cNvPr id="11" name="Text 9"/>
-          <p:cNvSpPr/>
-          <p:nvPr/>
-        </p:nvSpPr>
-        <p:spPr>
-          <a:xfrm>
-            <a:off x="822960" y="4105656"/>
-            <a:ext cx="4434840" cy="841248"/>
-          </a:xfrm>
-          <a:prstGeom prst="rect">
-            <a:avLst/>
-          </a:prstGeom>
-          <a:noFill/>
-          <a:ln/>
-        </p:spPr>
-        <p:txBody>
-          <a:bodyPr wrap="square" lIns="0" tIns="0" rIns="0" bIns="0" rtlCol="0" anchor="ctr"/>
-          <a:lstStyle/>
-          <a:p>
-            <a:pPr indent="0" marL="0">
-              <a:buNone/>
-            </a:pPr>
-            <a:r>
-              <a:rPr lang="en-US" sz="1350" b="1" dirty="0">
-                <a:solidFill>
-                  <a:srgbClr val="1E2761"/>
-                </a:solidFill>
-                <a:latin typeface="Calibri" pitchFamily="34" charset="0"/>
-                <a:ea typeface="Calibri" pitchFamily="34" charset="-122"/>
-                <a:cs typeface="Calibri" pitchFamily="34" charset="-120"/>
-              </a:rPr>
-              <a:t>Unified database</a:t>
-            </a:r>
-            <a:pPr indent="0" marL="0">
-              <a:buNone/>
-            </a:pPr>
-            <a:r>
-              <a:rPr lang="en-US" sz="1350" dirty="0">
-                <a:solidFill>
-                  <a:srgbClr val="44546A"/>
-                </a:solidFill>
-                <a:latin typeface="Calibri" pitchFamily="34" charset="0"/>
-                <a:ea typeface="Calibri" pitchFamily="34" charset="-122"/>
-                <a:cs typeface="Calibri" pitchFamily="34" charset="-120"/>
-              </a:rPr>
-              <a:t>  —  cell inventory joined to every KPI</a:t>
-            </a:r>
-            <a:endParaRPr lang="en-US" sz="1350" dirty="0"/>
-          </a:p>
-        </p:txBody>
-      </p:sp>
-      <p:sp>
-        <p:nvSpPr>
-          <p:cNvPr id="12" name="Shape 10"/>
-          <p:cNvSpPr/>
-          <p:nvPr/>
-        </p:nvSpPr>
-        <p:spPr>
-          <a:xfrm flipV="1">
-            <a:off x="2894076" y="5015484"/>
-            <a:ext cx="201168" cy="173736"/>
+          <p:cNvPr id="17" name="Shape 15"/>
+          <p:cNvSpPr/>
+          <p:nvPr/>
+        </p:nvSpPr>
+        <p:spPr>
+          <a:xfrm rot="5400000">
+            <a:off x="7808976" y="2546604"/>
+            <a:ext cx="384048" cy="347472"/>
           </a:xfrm>
           <a:prstGeom prst="triangle">
             <a:avLst/>
@@ -2158,89 +2677,14 @@
       </p:sp>
       <p:sp>
         <p:nvSpPr>
-          <p:cNvPr id="13" name="Shape 11"/>
-          <p:cNvSpPr/>
-          <p:nvPr/>
-        </p:nvSpPr>
-        <p:spPr>
-          <a:xfrm>
-            <a:off x="548640" y="5266944"/>
-            <a:ext cx="4892040" cy="841248"/>
-          </a:xfrm>
-          <a:prstGeom prst="roundRect">
-            <a:avLst>
-              <a:gd name="adj" fmla="val 8696"/>
-            </a:avLst>
-          </a:prstGeom>
-          <a:solidFill>
-            <a:srgbClr val="1E2761"/>
-          </a:solidFill>
-          <a:ln/>
-        </p:spPr>
-      </p:sp>
-      <p:sp>
-        <p:nvSpPr>
-          <p:cNvPr id="14" name="Text 12"/>
-          <p:cNvSpPr/>
-          <p:nvPr/>
-        </p:nvSpPr>
-        <p:spPr>
-          <a:xfrm>
-            <a:off x="822960" y="5266944"/>
-            <a:ext cx="4434840" cy="841248"/>
-          </a:xfrm>
-          <a:prstGeom prst="rect">
-            <a:avLst/>
-          </a:prstGeom>
-          <a:noFill/>
-          <a:ln/>
-        </p:spPr>
-        <p:txBody>
-          <a:bodyPr wrap="square" lIns="0" tIns="0" rIns="0" bIns="0" rtlCol="0" anchor="ctr"/>
-          <a:lstStyle/>
-          <a:p>
-            <a:pPr indent="0" marL="0">
-              <a:buNone/>
-            </a:pPr>
-            <a:r>
-              <a:rPr lang="en-US" sz="1350" b="1" dirty="0">
-                <a:solidFill>
-                  <a:srgbClr val="FFFFFF"/>
-                </a:solidFill>
-                <a:latin typeface="Calibri" pitchFamily="34" charset="0"/>
-                <a:ea typeface="Calibri" pitchFamily="34" charset="-122"/>
-                <a:cs typeface="Calibri" pitchFamily="34" charset="-120"/>
-              </a:rPr>
-              <a:t>~40 analysis tools</a:t>
-            </a:r>
-            <a:pPr indent="0" marL="0">
-              <a:buNone/>
-            </a:pPr>
-            <a:r>
-              <a:rPr lang="en-US" sz="1350" dirty="0">
-                <a:solidFill>
-                  <a:srgbClr val="CADCFC"/>
-                </a:solidFill>
-                <a:latin typeface="Calibri" pitchFamily="34" charset="0"/>
-                <a:ea typeface="Calibri" pitchFamily="34" charset="-122"/>
-                <a:cs typeface="Calibri" pitchFamily="34" charset="-120"/>
-              </a:rPr>
-              <a:t>  —  one login, one web UI</a:t>
-            </a:r>
-            <a:endParaRPr lang="en-US" sz="1350" dirty="0"/>
-          </a:p>
-        </p:txBody>
-      </p:sp>
-      <p:sp>
-        <p:nvSpPr>
-          <p:cNvPr id="15" name="Shape 13"/>
-          <p:cNvSpPr/>
-          <p:nvPr/>
-        </p:nvSpPr>
-        <p:spPr>
-          <a:xfrm>
-            <a:off x="5989320" y="1911096"/>
-            <a:ext cx="566928" cy="566928"/>
+          <p:cNvPr id="18" name="Shape 16"/>
+          <p:cNvSpPr/>
+          <p:nvPr/>
+        </p:nvSpPr>
+        <p:spPr>
+          <a:xfrm>
+            <a:off x="932688" y="4069080"/>
+            <a:ext cx="502920" cy="502920"/>
           </a:xfrm>
           <a:prstGeom prst="ellipse">
             <a:avLst/>
@@ -2253,7 +2697,7 @@
       </p:sp>
       <p:pic>
         <p:nvPicPr>
-          <p:cNvPr id="16" name="Image 0" descr="preencoded.png">    </p:cNvPr>
+          <p:cNvPr id="19" name="Image 0" descr="preencoded.png">    </p:cNvPr>
           <p:cNvPicPr>
             <a:picLocks noChangeAspect="1"/>
           </p:cNvPicPr>
@@ -2267,8 +2711,8 @@
         </p:blipFill>
         <p:spPr>
           <a:xfrm>
-            <a:off x="6125383" y="2047159"/>
-            <a:ext cx="294803" cy="294803"/>
+            <a:off x="1053389" y="4189781"/>
+            <a:ext cx="261518" cy="261518"/>
           </a:xfrm>
           <a:prstGeom prst="rect">
             <a:avLst/>
@@ -2277,14 +2721,14 @@
       </p:pic>
       <p:sp>
         <p:nvSpPr>
-          <p:cNvPr id="17" name="Text 14"/>
-          <p:cNvSpPr/>
-          <p:nvPr/>
-        </p:nvSpPr>
-        <p:spPr>
-          <a:xfrm>
-            <a:off x="6812280" y="1783080"/>
-            <a:ext cx="5349240" cy="347472"/>
+          <p:cNvPr id="20" name="Text 17"/>
+          <p:cNvSpPr/>
+          <p:nvPr/>
+        </p:nvSpPr>
+        <p:spPr>
+          <a:xfrm>
+            <a:off x="1618488" y="4069080"/>
+            <a:ext cx="2240280" cy="274320"/>
           </a:xfrm>
           <a:prstGeom prst="rect">
             <a:avLst/>
@@ -2300,7 +2744,7 @@
               <a:buNone/>
             </a:pPr>
             <a:r>
-              <a:rPr lang="en-US" sz="1600" b="1" dirty="0">
+              <a:rPr lang="en-US" sz="1450" b="1" dirty="0">
                 <a:solidFill>
                   <a:srgbClr val="1E2761"/>
                 </a:solidFill>
@@ -2308,38 +2752,38 @@
                 <a:ea typeface="Calibri" pitchFamily="34" charset="-122"/>
                 <a:cs typeface="Calibri" pitchFamily="34" charset="-120"/>
               </a:rPr>
-              <a:t>Optimization detectors</a:t>
-            </a:r>
-            <a:endParaRPr lang="en-US" sz="1600" dirty="0"/>
-          </a:p>
-        </p:txBody>
-      </p:sp>
-      <p:sp>
-        <p:nvSpPr>
-          <p:cNvPr id="18" name="Text 15"/>
-          <p:cNvSpPr/>
-          <p:nvPr/>
-        </p:nvSpPr>
-        <p:spPr>
-          <a:xfrm>
-            <a:off x="6812280" y="2148840"/>
-            <a:ext cx="5349240" cy="658368"/>
-          </a:xfrm>
-          <a:prstGeom prst="rect">
-            <a:avLst/>
-          </a:prstGeom>
-          <a:noFill/>
-          <a:ln/>
-        </p:spPr>
-        <p:txBody>
-          <a:bodyPr wrap="square" lIns="0" tIns="0" rIns="0" bIns="0" rtlCol="0" anchor="t"/>
+              <a:t>Monitor</a:t>
+            </a:r>
+            <a:endParaRPr lang="en-US" sz="1450" dirty="0"/>
+          </a:p>
+        </p:txBody>
+      </p:sp>
+      <p:sp>
+        <p:nvSpPr>
+          <p:cNvPr id="21" name="Text 18"/>
+          <p:cNvSpPr/>
+          <p:nvPr/>
+        </p:nvSpPr>
+        <p:spPr>
+          <a:xfrm>
+            <a:off x="1618488" y="4343400"/>
+            <a:ext cx="2240280" cy="274320"/>
+          </a:xfrm>
+          <a:prstGeom prst="rect">
+            <a:avLst/>
+          </a:prstGeom>
+          <a:noFill/>
+          <a:ln/>
+        </p:spPr>
+        <p:txBody>
+          <a:bodyPr wrap="square" lIns="0" tIns="0" rIns="0" bIns="0" rtlCol="0" anchor="ctr"/>
           <a:lstStyle/>
           <a:p>
             <a:pPr indent="0" marL="0">
               <a:buNone/>
             </a:pPr>
             <a:r>
-              <a:rPr lang="en-US" sz="1250" dirty="0">
+              <a:rPr lang="en-US" sz="1100" dirty="0">
                 <a:solidFill>
                   <a:srgbClr val="44546A"/>
                 </a:solidFill>
@@ -2347,22 +2791,22 @@
                 <a:ea typeface="Calibri" pitchFamily="34" charset="-122"/>
                 <a:cs typeface="Calibri" pitchFamily="34" charset="-120"/>
               </a:rPr>
-              <a:t>Sleeping cells, neighbor quality, cross-KPI insights — automatic, vendor-agnostic scoring of the whole network.</a:t>
-            </a:r>
-            <a:endParaRPr lang="en-US" sz="1250" dirty="0"/>
-          </a:p>
-        </p:txBody>
-      </p:sp>
-      <p:sp>
-        <p:nvSpPr>
-          <p:cNvPr id="19" name="Shape 16"/>
-          <p:cNvSpPr/>
-          <p:nvPr/>
-        </p:nvSpPr>
-        <p:spPr>
-          <a:xfrm>
-            <a:off x="5989320" y="3072384"/>
-            <a:ext cx="566928" cy="566928"/>
+              <a:t>live KPIs &amp; network health</a:t>
+            </a:r>
+            <a:endParaRPr lang="en-US" sz="1100" dirty="0"/>
+          </a:p>
+        </p:txBody>
+      </p:sp>
+      <p:sp>
+        <p:nvSpPr>
+          <p:cNvPr id="22" name="Shape 19"/>
+          <p:cNvSpPr/>
+          <p:nvPr/>
+        </p:nvSpPr>
+        <p:spPr>
+          <a:xfrm>
+            <a:off x="4773168" y="4069080"/>
+            <a:ext cx="502920" cy="502920"/>
           </a:xfrm>
           <a:prstGeom prst="ellipse">
             <a:avLst/>
@@ -2375,7 +2819,7 @@
       </p:sp>
       <p:pic>
         <p:nvPicPr>
-          <p:cNvPr id="20" name="Image 1" descr="preencoded.png">    </p:cNvPr>
+          <p:cNvPr id="23" name="Image 1" descr="preencoded.png">    </p:cNvPr>
           <p:cNvPicPr>
             <a:picLocks noChangeAspect="1"/>
           </p:cNvPicPr>
@@ -2389,8 +2833,8 @@
         </p:blipFill>
         <p:spPr>
           <a:xfrm>
-            <a:off x="6125383" y="3208447"/>
-            <a:ext cx="294803" cy="294803"/>
+            <a:off x="4893869" y="4189781"/>
+            <a:ext cx="261518" cy="261518"/>
           </a:xfrm>
           <a:prstGeom prst="rect">
             <a:avLst/>
@@ -2399,14 +2843,14 @@
       </p:pic>
       <p:sp>
         <p:nvSpPr>
-          <p:cNvPr id="21" name="Text 17"/>
-          <p:cNvSpPr/>
-          <p:nvPr/>
-        </p:nvSpPr>
-        <p:spPr>
-          <a:xfrm>
-            <a:off x="6812280" y="2944368"/>
-            <a:ext cx="5349240" cy="347472"/>
+          <p:cNvPr id="24" name="Text 20"/>
+          <p:cNvSpPr/>
+          <p:nvPr/>
+        </p:nvSpPr>
+        <p:spPr>
+          <a:xfrm>
+            <a:off x="5458968" y="4069080"/>
+            <a:ext cx="2240280" cy="274320"/>
           </a:xfrm>
           <a:prstGeom prst="rect">
             <a:avLst/>
@@ -2422,7 +2866,7 @@
               <a:buNone/>
             </a:pPr>
             <a:r>
-              <a:rPr lang="en-US" sz="1600" b="1" dirty="0">
+              <a:rPr lang="en-US" sz="1450" b="1" dirty="0">
                 <a:solidFill>
                   <a:srgbClr val="1E2761"/>
                 </a:solidFill>
@@ -2430,38 +2874,38 @@
                 <a:ea typeface="Calibri" pitchFamily="34" charset="-122"/>
                 <a:cs typeface="Calibri" pitchFamily="34" charset="-120"/>
               </a:rPr>
-              <a:t>Configuration management</a:t>
-            </a:r>
-            <a:endParaRPr lang="en-US" sz="1600" dirty="0"/>
-          </a:p>
-        </p:txBody>
-      </p:sp>
-      <p:sp>
-        <p:nvSpPr>
-          <p:cNvPr id="22" name="Text 18"/>
-          <p:cNvSpPr/>
-          <p:nvPr/>
-        </p:nvSpPr>
-        <p:spPr>
-          <a:xfrm>
-            <a:off x="6812280" y="3310128"/>
-            <a:ext cx="5349240" cy="658368"/>
-          </a:xfrm>
-          <a:prstGeom prst="rect">
-            <a:avLst/>
-          </a:prstGeom>
-          <a:noFill/>
-          <a:ln/>
-        </p:spPr>
-        <p:txBody>
-          <a:bodyPr wrap="square" lIns="0" tIns="0" rIns="0" bIns="0" rtlCol="0" anchor="t"/>
+              <a:t>Configure</a:t>
+            </a:r>
+            <a:endParaRPr lang="en-US" sz="1450" dirty="0"/>
+          </a:p>
+        </p:txBody>
+      </p:sp>
+      <p:sp>
+        <p:nvSpPr>
+          <p:cNvPr id="25" name="Text 21"/>
+          <p:cNvSpPr/>
+          <p:nvPr/>
+        </p:nvSpPr>
+        <p:spPr>
+          <a:xfrm>
+            <a:off x="5458968" y="4343400"/>
+            <a:ext cx="2240280" cy="274320"/>
+          </a:xfrm>
+          <a:prstGeom prst="rect">
+            <a:avLst/>
+          </a:prstGeom>
+          <a:noFill/>
+          <a:ln/>
+        </p:spPr>
+        <p:txBody>
+          <a:bodyPr wrap="square" lIns="0" tIns="0" rIns="0" bIns="0" rtlCol="0" anchor="ctr"/>
           <a:lstStyle/>
           <a:p>
             <a:pPr indent="0" marL="0">
               <a:buNone/>
             </a:pPr>
             <a:r>
-              <a:rPr lang="en-US" sz="1250" dirty="0">
+              <a:rPr lang="en-US" sz="1100" dirty="0">
                 <a:solidFill>
                   <a:srgbClr val="44546A"/>
                 </a:solidFill>
@@ -2469,22 +2913,22 @@
                 <a:ea typeface="Calibri" pitchFamily="34" charset="-122"/>
                 <a:cs typeface="Calibri" pitchFamily="34" charset="-120"/>
               </a:rPr>
-              <a:t>Live config extraction from network elements, parameter audits, change history and remote tilt management.</a:t>
-            </a:r>
-            <a:endParaRPr lang="en-US" sz="1250" dirty="0"/>
-          </a:p>
-        </p:txBody>
-      </p:sp>
-      <p:sp>
-        <p:nvSpPr>
-          <p:cNvPr id="23" name="Shape 19"/>
-          <p:cNvSpPr/>
-          <p:nvPr/>
-        </p:nvSpPr>
-        <p:spPr>
-          <a:xfrm>
-            <a:off x="5989320" y="4233672"/>
-            <a:ext cx="566928" cy="566928"/>
+              <a:t>parameters &amp; change control</a:t>
+            </a:r>
+            <a:endParaRPr lang="en-US" sz="1100" dirty="0"/>
+          </a:p>
+        </p:txBody>
+      </p:sp>
+      <p:sp>
+        <p:nvSpPr>
+          <p:cNvPr id="26" name="Shape 22"/>
+          <p:cNvSpPr/>
+          <p:nvPr/>
+        </p:nvSpPr>
+        <p:spPr>
+          <a:xfrm>
+            <a:off x="8613648" y="4069080"/>
+            <a:ext cx="502920" cy="502920"/>
           </a:xfrm>
           <a:prstGeom prst="ellipse">
             <a:avLst/>
@@ -2497,7 +2941,7 @@
       </p:sp>
       <p:pic>
         <p:nvPicPr>
-          <p:cNvPr id="24" name="Image 2" descr="preencoded.png">    </p:cNvPr>
+          <p:cNvPr id="27" name="Image 2" descr="preencoded.png">    </p:cNvPr>
           <p:cNvPicPr>
             <a:picLocks noChangeAspect="1"/>
           </p:cNvPicPr>
@@ -2511,8 +2955,8 @@
         </p:blipFill>
         <p:spPr>
           <a:xfrm>
-            <a:off x="6125383" y="4369735"/>
-            <a:ext cx="294803" cy="294803"/>
+            <a:off x="8734349" y="4189781"/>
+            <a:ext cx="261518" cy="261518"/>
           </a:xfrm>
           <a:prstGeom prst="rect">
             <a:avLst/>
@@ -2521,14 +2965,14 @@
       </p:pic>
       <p:sp>
         <p:nvSpPr>
-          <p:cNvPr id="25" name="Text 20"/>
-          <p:cNvSpPr/>
-          <p:nvPr/>
-        </p:nvSpPr>
-        <p:spPr>
-          <a:xfrm>
-            <a:off x="6812280" y="4105656"/>
-            <a:ext cx="5349240" cy="347472"/>
+          <p:cNvPr id="28" name="Text 23"/>
+          <p:cNvSpPr/>
+          <p:nvPr/>
+        </p:nvSpPr>
+        <p:spPr>
+          <a:xfrm>
+            <a:off x="9299448" y="4069080"/>
+            <a:ext cx="2240280" cy="274320"/>
           </a:xfrm>
           <a:prstGeom prst="rect">
             <a:avLst/>
@@ -2544,7 +2988,7 @@
               <a:buNone/>
             </a:pPr>
             <a:r>
-              <a:rPr lang="en-US" sz="1600" b="1" dirty="0">
+              <a:rPr lang="en-US" sz="1450" b="1" dirty="0">
                 <a:solidFill>
                   <a:srgbClr val="1E2761"/>
                 </a:solidFill>
@@ -2552,22 +2996,61 @@
                 <a:ea typeface="Calibri" pitchFamily="34" charset="-122"/>
                 <a:cs typeface="Calibri" pitchFamily="34" charset="-120"/>
               </a:rPr>
-              <a:t>Maps &amp; reporting</a:t>
-            </a:r>
-            <a:endParaRPr lang="en-US" sz="1600" dirty="0"/>
-          </a:p>
-        </p:txBody>
-      </p:sp>
-      <p:sp>
-        <p:nvSpPr>
-          <p:cNvPr id="26" name="Text 21"/>
-          <p:cNvSpPr/>
-          <p:nvPr/>
-        </p:nvSpPr>
-        <p:spPr>
-          <a:xfrm>
-            <a:off x="6812280" y="4471416"/>
-            <a:ext cx="5349240" cy="658368"/>
+              <a:t>Optimize</a:t>
+            </a:r>
+            <a:endParaRPr lang="en-US" sz="1450" dirty="0"/>
+          </a:p>
+        </p:txBody>
+      </p:sp>
+      <p:sp>
+        <p:nvSpPr>
+          <p:cNvPr id="29" name="Text 24"/>
+          <p:cNvSpPr/>
+          <p:nvPr/>
+        </p:nvSpPr>
+        <p:spPr>
+          <a:xfrm>
+            <a:off x="9299448" y="4343400"/>
+            <a:ext cx="2240280" cy="274320"/>
+          </a:xfrm>
+          <a:prstGeom prst="rect">
+            <a:avLst/>
+          </a:prstGeom>
+          <a:noFill/>
+          <a:ln/>
+        </p:spPr>
+        <p:txBody>
+          <a:bodyPr wrap="square" lIns="0" tIns="0" rIns="0" bIns="0" rtlCol="0" anchor="ctr"/>
+          <a:lstStyle/>
+          <a:p>
+            <a:pPr indent="0" marL="0">
+              <a:buNone/>
+            </a:pPr>
+            <a:r>
+              <a:rPr lang="en-US" sz="1100" dirty="0">
+                <a:solidFill>
+                  <a:srgbClr val="44546A"/>
+                </a:solidFill>
+                <a:latin typeface="Calibri" pitchFamily="34" charset="0"/>
+                <a:ea typeface="Calibri" pitchFamily="34" charset="-122"/>
+                <a:cs typeface="Calibri" pitchFamily="34" charset="-120"/>
+              </a:rPr>
+              <a:t>detectors &amp; tuning actions</a:t>
+            </a:r>
+            <a:endParaRPr lang="en-US" sz="1100" dirty="0"/>
+          </a:p>
+        </p:txBody>
+      </p:sp>
+      <p:sp>
+        <p:nvSpPr>
+          <p:cNvPr id="30" name="Text 25"/>
+          <p:cNvSpPr/>
+          <p:nvPr/>
+        </p:nvSpPr>
+        <p:spPr>
+          <a:xfrm>
+            <a:off x="658368" y="5257800"/>
+            <a:ext cx="10881360" cy="914400"/>
           </a:xfrm>
           <a:prstGeom prst="rect">
             <a:avLst/>
@@ -2583,7 +3066,21 @@
               <a:buNone/>
             </a:pPr>
             <a:r>
-              <a:rPr lang="en-US" sz="1250" dirty="0">
+              <a:rPr lang="en-US" sz="1450" b="1" dirty="0">
+                <a:solidFill>
+                  <a:srgbClr val="1E2761"/>
+                </a:solidFill>
+                <a:latin typeface="Calibri" pitchFamily="34" charset="0"/>
+                <a:ea typeface="Calibri" pitchFamily="34" charset="-122"/>
+                <a:cs typeface="Calibri" pitchFamily="34" charset="-120"/>
+              </a:rPr>
+              <a:t>One single, web-based dashboard </a:t>
+            </a:r>
+            <a:pPr indent="0" marL="0">
+              <a:buNone/>
+            </a:pPr>
+            <a:r>
+              <a:rPr lang="en-US" sz="1450" dirty="0">
                 <a:solidFill>
                   <a:srgbClr val="44546A"/>
                 </a:solidFill>
@@ -2591,131 +3088,9 @@
                 <a:ea typeface="Calibri" pitchFamily="34" charset="-122"/>
                 <a:cs typeface="Calibri" pitchFamily="34" charset="-120"/>
               </a:rPr>
-              <a:t>Network map, coverage heatmaps, drive-test viewer, KPI explorer and an automated morning report.</a:t>
-            </a:r>
-            <a:endParaRPr lang="en-US" sz="1250" dirty="0"/>
-          </a:p>
-        </p:txBody>
-      </p:sp>
-      <p:sp>
-        <p:nvSpPr>
-          <p:cNvPr id="27" name="Shape 22"/>
-          <p:cNvSpPr/>
-          <p:nvPr/>
-        </p:nvSpPr>
-        <p:spPr>
-          <a:xfrm>
-            <a:off x="5989320" y="5394960"/>
-            <a:ext cx="566928" cy="566928"/>
-          </a:xfrm>
-          <a:prstGeom prst="ellipse">
-            <a:avLst/>
-          </a:prstGeom>
-          <a:solidFill>
-            <a:srgbClr val="02C39A"/>
-          </a:solidFill>
-          <a:ln/>
-        </p:spPr>
-      </p:sp>
-      <p:pic>
-        <p:nvPicPr>
-          <p:cNvPr id="28" name="Image 3" descr="preencoded.png">    </p:cNvPr>
-          <p:cNvPicPr>
-            <a:picLocks noChangeAspect="1"/>
-          </p:cNvPicPr>
-          <p:nvPr/>
-        </p:nvPicPr>
-        <p:blipFill>
-          <a:blip r:embed="rId4"/>
-          <a:stretch>
-            <a:fillRect/>
-          </a:stretch>
-        </p:blipFill>
-        <p:spPr>
-          <a:xfrm>
-            <a:off x="6125383" y="5531023"/>
-            <a:ext cx="294803" cy="294803"/>
-          </a:xfrm>
-          <a:prstGeom prst="rect">
-            <a:avLst/>
-          </a:prstGeom>
-        </p:spPr>
-      </p:pic>
-      <p:sp>
-        <p:nvSpPr>
-          <p:cNvPr id="29" name="Text 23"/>
-          <p:cNvSpPr/>
-          <p:nvPr/>
-        </p:nvSpPr>
-        <p:spPr>
-          <a:xfrm>
-            <a:off x="6812280" y="5266944"/>
-            <a:ext cx="5349240" cy="347472"/>
-          </a:xfrm>
-          <a:prstGeom prst="rect">
-            <a:avLst/>
-          </a:prstGeom>
-          <a:noFill/>
-          <a:ln/>
-        </p:spPr>
-        <p:txBody>
-          <a:bodyPr wrap="square" lIns="0" tIns="0" rIns="0" bIns="0" rtlCol="0" anchor="ctr"/>
-          <a:lstStyle/>
-          <a:p>
-            <a:pPr indent="0" marL="0">
-              <a:buNone/>
-            </a:pPr>
-            <a:r>
-              <a:rPr lang="en-US" sz="1600" b="1" dirty="0">
-                <a:solidFill>
-                  <a:srgbClr val="1E2761"/>
-                </a:solidFill>
-                <a:latin typeface="Calibri" pitchFamily="34" charset="0"/>
-                <a:ea typeface="Calibri" pitchFamily="34" charset="-122"/>
-                <a:cs typeface="Calibri" pitchFamily="34" charset="-120"/>
-              </a:rPr>
-              <a:t>Secure &amp; self-hosted</a:t>
-            </a:r>
-            <a:endParaRPr lang="en-US" sz="1600" dirty="0"/>
-          </a:p>
-        </p:txBody>
-      </p:sp>
-      <p:sp>
-        <p:nvSpPr>
-          <p:cNvPr id="30" name="Text 24"/>
-          <p:cNvSpPr/>
-          <p:nvPr/>
-        </p:nvSpPr>
-        <p:spPr>
-          <a:xfrm>
-            <a:off x="6812280" y="5632704"/>
-            <a:ext cx="5349240" cy="658368"/>
-          </a:xfrm>
-          <a:prstGeom prst="rect">
-            <a:avLst/>
-          </a:prstGeom>
-          <a:noFill/>
-          <a:ln/>
-        </p:spPr>
-        <p:txBody>
-          <a:bodyPr wrap="square" lIns="0" tIns="0" rIns="0" bIns="0" rtlCol="0" anchor="t"/>
-          <a:lstStyle/>
-          <a:p>
-            <a:pPr indent="0" marL="0">
-              <a:buNone/>
-            </a:pPr>
-            <a:r>
-              <a:rPr lang="en-US" sz="1250" dirty="0">
-                <a:solidFill>
-                  <a:srgbClr val="44546A"/>
-                </a:solidFill>
-                <a:latin typeface="Calibri" pitchFamily="34" charset="0"/>
-                <a:ea typeface="Calibri" pitchFamily="34" charset="-122"/>
-                <a:cs typeface="Calibri" pitchFamily="34" charset="-120"/>
-              </a:rPr>
-              <a:t>Role-based access, licensing gate and hardened web security — deployed on our own servers via Docker.</a:t>
-            </a:r>
-            <a:endParaRPr lang="en-US" sz="1250" dirty="0"/>
+              <a:t>consolidates multi-vendor and multi-RAT engineering into one place — stripping away technical complexity so engineers monitor, configure and optimize everything, regardless of the hardware provider.</a:t>
+            </a:r>
+            <a:endParaRPr lang="en-US" sz="1450" dirty="0"/>
           </a:p>
         </p:txBody>
       </p:sp>
@@ -2760,7 +3135,7 @@
         <p:spPr>
           <a:xfrm>
             <a:off x="548640" y="384048"/>
-            <a:ext cx="5486400" cy="320040"/>
+            <a:ext cx="9144000" cy="320040"/>
           </a:xfrm>
           <a:prstGeom prst="rect">
             <a:avLst/>
@@ -2784,7 +3159,7 @@
                 <a:ea typeface="Calibri" pitchFamily="34" charset="-122"/>
                 <a:cs typeface="Calibri" pitchFamily="34" charset="-120"/>
               </a:rPr>
-              <a:t>THE ADDED VALUE</a:t>
+              <a:t>THE VISION &amp; ROI — INTERNAL TOOL TO GLOBAL SAAS</a:t>
             </a:r>
             <a:endParaRPr lang="en-US" sz="1300" dirty="0"/>
           </a:p>
@@ -2799,7 +3174,7 @@
         <p:spPr>
           <a:xfrm>
             <a:off x="548640" y="713232"/>
-            <a:ext cx="11064240" cy="731520"/>
+            <a:ext cx="11064240" cy="658368"/>
           </a:xfrm>
           <a:prstGeom prst="rect">
             <a:avLst/>
@@ -2815,7 +3190,7 @@
               <a:buNone/>
             </a:pPr>
             <a:r>
-              <a:rPr lang="en-US" sz="3700" b="1" dirty="0">
+              <a:rPr lang="en-US" sz="3100" b="1" dirty="0">
                 <a:solidFill>
                   <a:srgbClr val="FFFFFF"/>
                 </a:solidFill>
@@ -2823,338 +3198,26 @@
                 <a:ea typeface="Calibri" pitchFamily="34" charset="-122"/>
                 <a:cs typeface="Calibri" pitchFamily="34" charset="-120"/>
               </a:rPr>
-              <a:t>What PrimeNet Delivers</a:t>
-            </a:r>
-            <a:endParaRPr lang="en-US" sz="3700" dirty="0"/>
-          </a:p>
-        </p:txBody>
-      </p:sp>
-      <p:sp>
-        <p:nvSpPr>
-          <p:cNvPr id="4" name="Text 2"/>
+              <a:t>Slashing Internal OpEx Today, Commercializing Tomorrow</a:t>
+            </a:r>
+            <a:endParaRPr lang="en-US" sz="3100" dirty="0"/>
+          </a:p>
+        </p:txBody>
+      </p:sp>
+      <p:sp>
+        <p:nvSpPr>
+          <p:cNvPr id="4" name="Shape 2"/>
           <p:cNvSpPr/>
           <p:nvPr/>
         </p:nvSpPr>
         <p:spPr>
           <a:xfrm>
             <a:off x="548640" y="1645920"/>
-            <a:ext cx="2770632" cy="685800"/>
-          </a:xfrm>
-          <a:prstGeom prst="rect">
-            <a:avLst/>
-          </a:prstGeom>
-          <a:noFill/>
-          <a:ln/>
-        </p:spPr>
-        <p:txBody>
-          <a:bodyPr wrap="square" lIns="0" tIns="0" rIns="0" bIns="0" rtlCol="0" anchor="ctr"/>
-          <a:lstStyle/>
-          <a:p>
-            <a:pPr algn="ctr" indent="0" marL="0">
-              <a:buNone/>
-            </a:pPr>
-            <a:r>
-              <a:rPr lang="en-US" sz="4400" b="1" dirty="0">
-                <a:solidFill>
-                  <a:srgbClr val="02C39A"/>
-                </a:solidFill>
-                <a:latin typeface="Calibri" pitchFamily="34" charset="0"/>
-                <a:ea typeface="Calibri" pitchFamily="34" charset="-122"/>
-                <a:cs typeface="Calibri" pitchFamily="34" charset="-120"/>
-              </a:rPr>
-              <a:t>2</a:t>
-            </a:r>
-            <a:endParaRPr lang="en-US" sz="4400" dirty="0"/>
-          </a:p>
-        </p:txBody>
-      </p:sp>
-      <p:sp>
-        <p:nvSpPr>
-          <p:cNvPr id="5" name="Text 3"/>
-          <p:cNvSpPr/>
-          <p:nvPr/>
-        </p:nvSpPr>
-        <p:spPr>
-          <a:xfrm>
-            <a:off x="548640" y="2359152"/>
-            <a:ext cx="2770632" cy="320040"/>
-          </a:xfrm>
-          <a:prstGeom prst="rect">
-            <a:avLst/>
-          </a:prstGeom>
-          <a:noFill/>
-          <a:ln/>
-        </p:spPr>
-        <p:txBody>
-          <a:bodyPr wrap="square" lIns="0" tIns="0" rIns="0" bIns="0" rtlCol="0" anchor="ctr"/>
-          <a:lstStyle/>
-          <a:p>
-            <a:pPr algn="ctr" indent="0" marL="0">
-              <a:buNone/>
-            </a:pPr>
-            <a:r>
-              <a:rPr lang="en-US" sz="1250" dirty="0">
-                <a:solidFill>
-                  <a:srgbClr val="CADCFC"/>
-                </a:solidFill>
-                <a:latin typeface="Calibri" pitchFamily="34" charset="0"/>
-                <a:ea typeface="Calibri" pitchFamily="34" charset="-122"/>
-                <a:cs typeface="Calibri" pitchFamily="34" charset="-120"/>
-              </a:rPr>
-              <a:t>vendors, one single view</a:t>
-            </a:r>
-            <a:endParaRPr lang="en-US" sz="1250" dirty="0"/>
-          </a:p>
-        </p:txBody>
-      </p:sp>
-      <p:sp>
-        <p:nvSpPr>
-          <p:cNvPr id="6" name="Text 4"/>
-          <p:cNvSpPr/>
-          <p:nvPr/>
-        </p:nvSpPr>
-        <p:spPr>
-          <a:xfrm>
-            <a:off x="3337560" y="1645920"/>
-            <a:ext cx="2770632" cy="685800"/>
-          </a:xfrm>
-          <a:prstGeom prst="rect">
-            <a:avLst/>
-          </a:prstGeom>
-          <a:noFill/>
-          <a:ln/>
-        </p:spPr>
-        <p:txBody>
-          <a:bodyPr wrap="square" lIns="0" tIns="0" rIns="0" bIns="0" rtlCol="0" anchor="ctr"/>
-          <a:lstStyle/>
-          <a:p>
-            <a:pPr algn="ctr" indent="0" marL="0">
-              <a:buNone/>
-            </a:pPr>
-            <a:r>
-              <a:rPr lang="en-US" sz="4400" b="1" dirty="0">
-                <a:solidFill>
-                  <a:srgbClr val="02C39A"/>
-                </a:solidFill>
-                <a:latin typeface="Calibri" pitchFamily="34" charset="0"/>
-                <a:ea typeface="Calibri" pitchFamily="34" charset="-122"/>
-                <a:cs typeface="Calibri" pitchFamily="34" charset="-120"/>
-              </a:rPr>
-              <a:t>2G–5G</a:t>
-            </a:r>
-            <a:endParaRPr lang="en-US" sz="4400" dirty="0"/>
-          </a:p>
-        </p:txBody>
-      </p:sp>
-      <p:sp>
-        <p:nvSpPr>
-          <p:cNvPr id="7" name="Text 5"/>
-          <p:cNvSpPr/>
-          <p:nvPr/>
-        </p:nvSpPr>
-        <p:spPr>
-          <a:xfrm>
-            <a:off x="3337560" y="2359152"/>
-            <a:ext cx="2770632" cy="320040"/>
-          </a:xfrm>
-          <a:prstGeom prst="rect">
-            <a:avLst/>
-          </a:prstGeom>
-          <a:noFill/>
-          <a:ln/>
-        </p:spPr>
-        <p:txBody>
-          <a:bodyPr wrap="square" lIns="0" tIns="0" rIns="0" bIns="0" rtlCol="0" anchor="ctr"/>
-          <a:lstStyle/>
-          <a:p>
-            <a:pPr algn="ctr" indent="0" marL="0">
-              <a:buNone/>
-            </a:pPr>
-            <a:r>
-              <a:rPr lang="en-US" sz="1250" dirty="0">
-                <a:solidFill>
-                  <a:srgbClr val="CADCFC"/>
-                </a:solidFill>
-                <a:latin typeface="Calibri" pitchFamily="34" charset="0"/>
-                <a:ea typeface="Calibri" pitchFamily="34" charset="-122"/>
-                <a:cs typeface="Calibri" pitchFamily="34" charset="-120"/>
-              </a:rPr>
-              <a:t>every radio technology</a:t>
-            </a:r>
-            <a:endParaRPr lang="en-US" sz="1250" dirty="0"/>
-          </a:p>
-        </p:txBody>
-      </p:sp>
-      <p:sp>
-        <p:nvSpPr>
-          <p:cNvPr id="8" name="Text 6"/>
-          <p:cNvSpPr/>
-          <p:nvPr/>
-        </p:nvSpPr>
-        <p:spPr>
-          <a:xfrm>
-            <a:off x="6126480" y="1645920"/>
-            <a:ext cx="2770632" cy="685800"/>
-          </a:xfrm>
-          <a:prstGeom prst="rect">
-            <a:avLst/>
-          </a:prstGeom>
-          <a:noFill/>
-          <a:ln/>
-        </p:spPr>
-        <p:txBody>
-          <a:bodyPr wrap="square" lIns="0" tIns="0" rIns="0" bIns="0" rtlCol="0" anchor="ctr"/>
-          <a:lstStyle/>
-          <a:p>
-            <a:pPr algn="ctr" indent="0" marL="0">
-              <a:buNone/>
-            </a:pPr>
-            <a:r>
-              <a:rPr lang="en-US" sz="4400" b="1" dirty="0">
-                <a:solidFill>
-                  <a:srgbClr val="02C39A"/>
-                </a:solidFill>
-                <a:latin typeface="Calibri" pitchFamily="34" charset="0"/>
-                <a:ea typeface="Calibri" pitchFamily="34" charset="-122"/>
-                <a:cs typeface="Calibri" pitchFamily="34" charset="-120"/>
-              </a:rPr>
-              <a:t>~40</a:t>
-            </a:r>
-            <a:endParaRPr lang="en-US" sz="4400" dirty="0"/>
-          </a:p>
-        </p:txBody>
-      </p:sp>
-      <p:sp>
-        <p:nvSpPr>
-          <p:cNvPr id="9" name="Text 7"/>
-          <p:cNvSpPr/>
-          <p:nvPr/>
-        </p:nvSpPr>
-        <p:spPr>
-          <a:xfrm>
-            <a:off x="6126480" y="2359152"/>
-            <a:ext cx="2770632" cy="320040"/>
-          </a:xfrm>
-          <a:prstGeom prst="rect">
-            <a:avLst/>
-          </a:prstGeom>
-          <a:noFill/>
-          <a:ln/>
-        </p:spPr>
-        <p:txBody>
-          <a:bodyPr wrap="square" lIns="0" tIns="0" rIns="0" bIns="0" rtlCol="0" anchor="ctr"/>
-          <a:lstStyle/>
-          <a:p>
-            <a:pPr algn="ctr" indent="0" marL="0">
-              <a:buNone/>
-            </a:pPr>
-            <a:r>
-              <a:rPr lang="en-US" sz="1250" dirty="0">
-                <a:solidFill>
-                  <a:srgbClr val="CADCFC"/>
-                </a:solidFill>
-                <a:latin typeface="Calibri" pitchFamily="34" charset="0"/>
-                <a:ea typeface="Calibri" pitchFamily="34" charset="-122"/>
-                <a:cs typeface="Calibri" pitchFamily="34" charset="-120"/>
-              </a:rPr>
-              <a:t>tools behind one login</a:t>
-            </a:r>
-            <a:endParaRPr lang="en-US" sz="1250" dirty="0"/>
-          </a:p>
-        </p:txBody>
-      </p:sp>
-      <p:sp>
-        <p:nvSpPr>
-          <p:cNvPr id="10" name="Text 8"/>
-          <p:cNvSpPr/>
-          <p:nvPr/>
-        </p:nvSpPr>
-        <p:spPr>
-          <a:xfrm>
-            <a:off x="8915400" y="1645920"/>
-            <a:ext cx="2770632" cy="685800"/>
-          </a:xfrm>
-          <a:prstGeom prst="rect">
-            <a:avLst/>
-          </a:prstGeom>
-          <a:noFill/>
-          <a:ln/>
-        </p:spPr>
-        <p:txBody>
-          <a:bodyPr wrap="square" lIns="0" tIns="0" rIns="0" bIns="0" rtlCol="0" anchor="ctr"/>
-          <a:lstStyle/>
-          <a:p>
-            <a:pPr algn="ctr" indent="0" marL="0">
-              <a:buNone/>
-            </a:pPr>
-            <a:r>
-              <a:rPr lang="en-US" sz="4400" b="1" dirty="0">
-                <a:solidFill>
-                  <a:srgbClr val="02C39A"/>
-                </a:solidFill>
-                <a:latin typeface="Calibri" pitchFamily="34" charset="0"/>
-                <a:ea typeface="Calibri" pitchFamily="34" charset="-122"/>
-                <a:cs typeface="Calibri" pitchFamily="34" charset="-120"/>
-              </a:rPr>
-              <a:t>24/7</a:t>
-            </a:r>
-            <a:endParaRPr lang="en-US" sz="4400" dirty="0"/>
-          </a:p>
-        </p:txBody>
-      </p:sp>
-      <p:sp>
-        <p:nvSpPr>
-          <p:cNvPr id="11" name="Text 9"/>
-          <p:cNvSpPr/>
-          <p:nvPr/>
-        </p:nvSpPr>
-        <p:spPr>
-          <a:xfrm>
-            <a:off x="8915400" y="2359152"/>
-            <a:ext cx="2770632" cy="320040"/>
-          </a:xfrm>
-          <a:prstGeom prst="rect">
-            <a:avLst/>
-          </a:prstGeom>
-          <a:noFill/>
-          <a:ln/>
-        </p:spPr>
-        <p:txBody>
-          <a:bodyPr wrap="square" lIns="0" tIns="0" rIns="0" bIns="0" rtlCol="0" anchor="ctr"/>
-          <a:lstStyle/>
-          <a:p>
-            <a:pPr algn="ctr" indent="0" marL="0">
-              <a:buNone/>
-            </a:pPr>
-            <a:r>
-              <a:rPr lang="en-US" sz="1250" dirty="0">
-                <a:solidFill>
-                  <a:srgbClr val="CADCFC"/>
-                </a:solidFill>
-                <a:latin typeface="Calibri" pitchFamily="34" charset="0"/>
-                <a:ea typeface="Calibri" pitchFamily="34" charset="-122"/>
-                <a:cs typeface="Calibri" pitchFamily="34" charset="-120"/>
-              </a:rPr>
-              <a:t>automated data collection</a:t>
-            </a:r>
-            <a:endParaRPr lang="en-US" sz="1250" dirty="0"/>
-          </a:p>
-        </p:txBody>
-      </p:sp>
-      <p:sp>
-        <p:nvSpPr>
-          <p:cNvPr id="12" name="Shape 10"/>
-          <p:cNvSpPr/>
-          <p:nvPr/>
-        </p:nvSpPr>
-        <p:spPr>
-          <a:xfrm>
-            <a:off x="548640" y="3063240"/>
-            <a:ext cx="3639312" cy="2514600"/>
+            <a:ext cx="5230368" cy="3611880"/>
           </a:xfrm>
           <a:prstGeom prst="roundRect">
             <a:avLst>
-              <a:gd name="adj" fmla="val 3273"/>
+              <a:gd name="adj" fmla="val 2278"/>
             </a:avLst>
           </a:prstGeom>
           <a:solidFill>
@@ -3165,13 +3228,13 @@
       </p:sp>
       <p:sp>
         <p:nvSpPr>
-          <p:cNvPr id="13" name="Shape 11"/>
-          <p:cNvSpPr/>
-          <p:nvPr/>
-        </p:nvSpPr>
-        <p:spPr>
-          <a:xfrm>
-            <a:off x="841248" y="3355848"/>
+          <p:cNvPr id="5" name="Shape 3"/>
+          <p:cNvSpPr/>
+          <p:nvPr/>
+        </p:nvSpPr>
+        <p:spPr>
+          <a:xfrm>
+            <a:off x="841248" y="1938528"/>
             <a:ext cx="566928" cy="566928"/>
           </a:xfrm>
           <a:prstGeom prst="ellipse">
@@ -3185,7 +3248,7 @@
       </p:sp>
       <p:pic>
         <p:nvPicPr>
-          <p:cNvPr id="14" name="Image 0" descr="preencoded.png">    </p:cNvPr>
+          <p:cNvPr id="6" name="Image 0" descr="preencoded.png">    </p:cNvPr>
           <p:cNvPicPr>
             <a:picLocks noChangeAspect="1"/>
           </p:cNvPicPr>
@@ -3199,7 +3262,7 @@
         </p:blipFill>
         <p:spPr>
           <a:xfrm>
-            <a:off x="977311" y="3491911"/>
+            <a:off x="977311" y="2074591"/>
             <a:ext cx="294803" cy="294803"/>
           </a:xfrm>
           <a:prstGeom prst="rect">
@@ -3209,14 +3272,14 @@
       </p:pic>
       <p:sp>
         <p:nvSpPr>
-          <p:cNvPr id="15" name="Text 12"/>
-          <p:cNvSpPr/>
-          <p:nvPr/>
-        </p:nvSpPr>
-        <p:spPr>
-          <a:xfrm>
-            <a:off x="841248" y="4050792"/>
-            <a:ext cx="3054096" cy="365760"/>
+          <p:cNvPr id="7" name="Text 4"/>
+          <p:cNvSpPr/>
+          <p:nvPr/>
+        </p:nvSpPr>
+        <p:spPr>
+          <a:xfrm>
+            <a:off x="1554480" y="1956816"/>
+            <a:ext cx="3950208" cy="256032"/>
           </a:xfrm>
           <a:prstGeom prst="rect">
             <a:avLst/>
@@ -3232,7 +3295,46 @@
               <a:buNone/>
             </a:pPr>
             <a:r>
-              <a:rPr lang="en-US" sz="1650" b="1" dirty="0">
+              <a:rPr lang="en-US" sz="1150" b="1" spc="200" kern="0" dirty="0">
+                <a:solidFill>
+                  <a:srgbClr val="02C39A"/>
+                </a:solidFill>
+                <a:latin typeface="Calibri" pitchFamily="34" charset="0"/>
+                <a:ea typeface="Calibri" pitchFamily="34" charset="-122"/>
+                <a:cs typeface="Calibri" pitchFamily="34" charset="-120"/>
+              </a:rPr>
+              <a:t>PHASE 1 · DEPLOY NOW</a:t>
+            </a:r>
+            <a:endParaRPr lang="en-US" sz="1150" dirty="0"/>
+          </a:p>
+        </p:txBody>
+      </p:sp>
+      <p:sp>
+        <p:nvSpPr>
+          <p:cNvPr id="8" name="Text 5"/>
+          <p:cNvSpPr/>
+          <p:nvPr/>
+        </p:nvSpPr>
+        <p:spPr>
+          <a:xfrm>
+            <a:off x="1554480" y="2194560"/>
+            <a:ext cx="3950208" cy="365760"/>
+          </a:xfrm>
+          <a:prstGeom prst="rect">
+            <a:avLst/>
+          </a:prstGeom>
+          <a:noFill/>
+          <a:ln/>
+        </p:spPr>
+        <p:txBody>
+          <a:bodyPr wrap="square" lIns="0" tIns="0" rIns="0" bIns="0" rtlCol="0" anchor="ctr"/>
+          <a:lstStyle/>
+          <a:p>
+            <a:pPr indent="0" marL="0">
+              <a:buNone/>
+            </a:pPr>
+            <a:r>
+              <a:rPr lang="en-US" sz="1800" b="1" dirty="0">
                 <a:solidFill>
                   <a:srgbClr val="FFFFFF"/>
                 </a:solidFill>
@@ -3240,22 +3342,100 @@
                 <a:ea typeface="Calibri" pitchFamily="34" charset="-122"/>
                 <a:cs typeface="Calibri" pitchFamily="34" charset="-120"/>
               </a:rPr>
-              <a:t>Proactive, not reactive</a:t>
-            </a:r>
-            <a:endParaRPr lang="en-US" sz="1650" dirty="0"/>
-          </a:p>
-        </p:txBody>
-      </p:sp>
-      <p:sp>
-        <p:nvSpPr>
-          <p:cNvPr id="16" name="Text 13"/>
-          <p:cNvSpPr/>
-          <p:nvPr/>
-        </p:nvSpPr>
-        <p:spPr>
-          <a:xfrm>
-            <a:off x="841248" y="4434840"/>
-            <a:ext cx="3054096" cy="1051560"/>
+              <a:t>Internal OpEx savings</a:t>
+            </a:r>
+            <a:endParaRPr lang="en-US" sz="1800" dirty="0"/>
+          </a:p>
+        </p:txBody>
+      </p:sp>
+      <p:sp>
+        <p:nvSpPr>
+          <p:cNvPr id="9" name="Text 6"/>
+          <p:cNvSpPr/>
+          <p:nvPr/>
+        </p:nvSpPr>
+        <p:spPr>
+          <a:xfrm>
+            <a:off x="841248" y="2788920"/>
+            <a:ext cx="4645152" cy="621792"/>
+          </a:xfrm>
+          <a:prstGeom prst="rect">
+            <a:avLst/>
+          </a:prstGeom>
+          <a:noFill/>
+          <a:ln/>
+        </p:spPr>
+        <p:txBody>
+          <a:bodyPr wrap="square" lIns="0" tIns="0" rIns="0" bIns="0" rtlCol="0" anchor="ctr"/>
+          <a:lstStyle/>
+          <a:p>
+            <a:pPr indent="0" marL="0">
+              <a:buNone/>
+            </a:pPr>
+            <a:r>
+              <a:rPr lang="en-US" sz="3800" b="1" dirty="0">
+                <a:solidFill>
+                  <a:srgbClr val="02C39A"/>
+                </a:solidFill>
+                <a:latin typeface="Calibri" pitchFamily="34" charset="0"/>
+                <a:ea typeface="Calibri" pitchFamily="34" charset="-122"/>
+                <a:cs typeface="Calibri" pitchFamily="34" charset="-120"/>
+              </a:rPr>
+              <a:t>30%</a:t>
+            </a:r>
+            <a:endParaRPr lang="en-US" sz="3800" dirty="0"/>
+          </a:p>
+        </p:txBody>
+      </p:sp>
+      <p:sp>
+        <p:nvSpPr>
+          <p:cNvPr id="10" name="Text 7"/>
+          <p:cNvSpPr/>
+          <p:nvPr/>
+        </p:nvSpPr>
+        <p:spPr>
+          <a:xfrm>
+            <a:off x="841248" y="3429000"/>
+            <a:ext cx="4645152" cy="292608"/>
+          </a:xfrm>
+          <a:prstGeom prst="rect">
+            <a:avLst/>
+          </a:prstGeom>
+          <a:noFill/>
+          <a:ln/>
+        </p:spPr>
+        <p:txBody>
+          <a:bodyPr wrap="square" lIns="0" tIns="0" rIns="0" bIns="0" rtlCol="0" anchor="ctr"/>
+          <a:lstStyle/>
+          <a:p>
+            <a:pPr indent="0" marL="0">
+              <a:buNone/>
+            </a:pPr>
+            <a:r>
+              <a:rPr lang="en-US" sz="1200" dirty="0">
+                <a:solidFill>
+                  <a:srgbClr val="CADCFC"/>
+                </a:solidFill>
+                <a:latin typeface="Calibri" pitchFamily="34" charset="0"/>
+                <a:ea typeface="Calibri" pitchFamily="34" charset="-122"/>
+                <a:cs typeface="Calibri" pitchFamily="34" charset="-120"/>
+              </a:rPr>
+              <a:t>efficiency gain across engineering workflows</a:t>
+            </a:r>
+            <a:endParaRPr lang="en-US" sz="1200" dirty="0"/>
+          </a:p>
+        </p:txBody>
+      </p:sp>
+      <p:sp>
+        <p:nvSpPr>
+          <p:cNvPr id="11" name="Text 8"/>
+          <p:cNvSpPr/>
+          <p:nvPr/>
+        </p:nvSpPr>
+        <p:spPr>
+          <a:xfrm>
+            <a:off x="932688" y="3931920"/>
+            <a:ext cx="4498848" cy="1188720"/>
           </a:xfrm>
           <a:prstGeom prst="rect">
             <a:avLst/>
@@ -3267,8 +3447,12 @@
           <a:bodyPr wrap="square" lIns="0" tIns="0" rIns="0" bIns="0" rtlCol="0" anchor="t"/>
           <a:lstStyle/>
           <a:p>
-            <a:pPr indent="0" marL="0">
-              <a:buNone/>
+            <a:pPr marL="152400" indent="-152400">
+              <a:spcAft>
+                <a:spcPts val="600"/>
+              </a:spcAft>
+              <a:buSzPct val="100000"/>
+              <a:buChar char="•"/>
             </a:pPr>
             <a:r>
               <a:rPr lang="en-US" sz="1250" dirty="0">
@@ -3279,26 +3463,68 @@
                 <a:ea typeface="Calibri" pitchFamily="34" charset="-122"/>
                 <a:cs typeface="Calibri" pitchFamily="34" charset="-120"/>
               </a:rPr>
-              <a:t>Degradations are detected and scored automatically every day — fixed before subscribers notice, not after they complain.</a:t>
+              <a:t>Instantly cut engineering cycle times</a:t>
             </a:r>
             <a:endParaRPr lang="en-US" sz="1250" dirty="0"/>
           </a:p>
-        </p:txBody>
-      </p:sp>
-      <p:sp>
-        <p:nvSpPr>
-          <p:cNvPr id="17" name="Shape 14"/>
-          <p:cNvSpPr/>
-          <p:nvPr/>
-        </p:nvSpPr>
-        <p:spPr>
-          <a:xfrm>
-            <a:off x="4261104" y="3063240"/>
-            <a:ext cx="3639312" cy="2514600"/>
+          <a:p>
+            <a:pPr marL="152400" indent="-152400">
+              <a:spcAft>
+                <a:spcPts val="600"/>
+              </a:spcAft>
+              <a:buSzPct val="100000"/>
+              <a:buChar char="•"/>
+            </a:pPr>
+            <a:r>
+              <a:rPr lang="en-US" sz="1250" dirty="0">
+                <a:solidFill>
+                  <a:srgbClr val="CADCFC"/>
+                </a:solidFill>
+                <a:latin typeface="Calibri" pitchFamily="34" charset="0"/>
+                <a:ea typeface="Calibri" pitchFamily="34" charset="-122"/>
+                <a:cs typeface="Calibri" pitchFamily="34" charset="-120"/>
+              </a:rPr>
+              <a:t>Reduce vendor software licensing fees</a:t>
+            </a:r>
+            <a:endParaRPr lang="en-US" sz="1250" dirty="0"/>
+          </a:p>
+          <a:p>
+            <a:pPr marL="152400" indent="-152400">
+              <a:spcAft>
+                <a:spcPts val="600"/>
+              </a:spcAft>
+              <a:buSzPct val="100000"/>
+              <a:buChar char="•"/>
+            </a:pPr>
+            <a:r>
+              <a:rPr lang="en-US" sz="1250" dirty="0">
+                <a:solidFill>
+                  <a:srgbClr val="CADCFC"/>
+                </a:solidFill>
+                <a:latin typeface="Calibri" pitchFamily="34" charset="0"/>
+                <a:ea typeface="Calibri" pitchFamily="34" charset="-122"/>
+                <a:cs typeface="Calibri" pitchFamily="34" charset="-120"/>
+              </a:rPr>
+              <a:t>One platform shared by every team</a:t>
+            </a:r>
+            <a:endParaRPr lang="en-US" sz="1250" dirty="0"/>
+          </a:p>
+        </p:txBody>
+      </p:sp>
+      <p:sp>
+        <p:nvSpPr>
+          <p:cNvPr id="12" name="Shape 9"/>
+          <p:cNvSpPr/>
+          <p:nvPr/>
+        </p:nvSpPr>
+        <p:spPr>
+          <a:xfrm>
+            <a:off x="6409944" y="1645920"/>
+            <a:ext cx="5230368" cy="3611880"/>
           </a:xfrm>
           <a:prstGeom prst="roundRect">
             <a:avLst>
-              <a:gd name="adj" fmla="val 3273"/>
+              <a:gd name="adj" fmla="val 2278"/>
             </a:avLst>
           </a:prstGeom>
           <a:solidFill>
@@ -3309,13 +3535,13 @@
       </p:sp>
       <p:sp>
         <p:nvSpPr>
-          <p:cNvPr id="18" name="Shape 15"/>
-          <p:cNvSpPr/>
-          <p:nvPr/>
-        </p:nvSpPr>
-        <p:spPr>
-          <a:xfrm>
-            <a:off x="4553712" y="3355848"/>
+          <p:cNvPr id="13" name="Shape 10"/>
+          <p:cNvSpPr/>
+          <p:nvPr/>
+        </p:nvSpPr>
+        <p:spPr>
+          <a:xfrm>
+            <a:off x="6702552" y="1938528"/>
             <a:ext cx="566928" cy="566928"/>
           </a:xfrm>
           <a:prstGeom prst="ellipse">
@@ -3329,7 +3555,7 @@
       </p:sp>
       <p:pic>
         <p:nvPicPr>
-          <p:cNvPr id="19" name="Image 1" descr="preencoded.png">    </p:cNvPr>
+          <p:cNvPr id="14" name="Image 1" descr="preencoded.png">    </p:cNvPr>
           <p:cNvPicPr>
             <a:picLocks noChangeAspect="1"/>
           </p:cNvPicPr>
@@ -3343,7 +3569,7 @@
         </p:blipFill>
         <p:spPr>
           <a:xfrm>
-            <a:off x="4689775" y="3491911"/>
+            <a:off x="6838615" y="2074591"/>
             <a:ext cx="294803" cy="294803"/>
           </a:xfrm>
           <a:prstGeom prst="rect">
@@ -3353,14 +3579,14 @@
       </p:pic>
       <p:sp>
         <p:nvSpPr>
-          <p:cNvPr id="20" name="Text 16"/>
-          <p:cNvSpPr/>
-          <p:nvPr/>
-        </p:nvSpPr>
-        <p:spPr>
-          <a:xfrm>
-            <a:off x="4553712" y="4050792"/>
-            <a:ext cx="3054096" cy="365760"/>
+          <p:cNvPr id="15" name="Text 11"/>
+          <p:cNvSpPr/>
+          <p:nvPr/>
+        </p:nvSpPr>
+        <p:spPr>
+          <a:xfrm>
+            <a:off x="7415784" y="1956816"/>
+            <a:ext cx="3950208" cy="256032"/>
           </a:xfrm>
           <a:prstGeom prst="rect">
             <a:avLst/>
@@ -3376,7 +3602,46 @@
               <a:buNone/>
             </a:pPr>
             <a:r>
-              <a:rPr lang="en-US" sz="1650" b="1" dirty="0">
+              <a:rPr lang="en-US" sz="1150" b="1" spc="200" kern="0" dirty="0">
+                <a:solidFill>
+                  <a:srgbClr val="02C39A"/>
+                </a:solidFill>
+                <a:latin typeface="Calibri" pitchFamily="34" charset="0"/>
+                <a:ea typeface="Calibri" pitchFamily="34" charset="-122"/>
+                <a:cs typeface="Calibri" pitchFamily="34" charset="-120"/>
+              </a:rPr>
+              <a:t>PHASE 2 · COMMERCIALIZE</a:t>
+            </a:r>
+            <a:endParaRPr lang="en-US" sz="1150" dirty="0"/>
+          </a:p>
+        </p:txBody>
+      </p:sp>
+      <p:sp>
+        <p:nvSpPr>
+          <p:cNvPr id="16" name="Text 12"/>
+          <p:cNvSpPr/>
+          <p:nvPr/>
+        </p:nvSpPr>
+        <p:spPr>
+          <a:xfrm>
+            <a:off x="7415784" y="2194560"/>
+            <a:ext cx="3950208" cy="365760"/>
+          </a:xfrm>
+          <a:prstGeom prst="rect">
+            <a:avLst/>
+          </a:prstGeom>
+          <a:noFill/>
+          <a:ln/>
+        </p:spPr>
+        <p:txBody>
+          <a:bodyPr wrap="square" lIns="0" tIns="0" rIns="0" bIns="0" rtlCol="0" anchor="ctr"/>
+          <a:lstStyle/>
+          <a:p>
+            <a:pPr indent="0" marL="0">
+              <a:buNone/>
+            </a:pPr>
+            <a:r>
+              <a:rPr lang="en-US" sz="1800" b="1" dirty="0">
                 <a:solidFill>
                   <a:srgbClr val="FFFFFF"/>
                 </a:solidFill>
@@ -3384,22 +3649,100 @@
                 <a:ea typeface="Calibri" pitchFamily="34" charset="-122"/>
                 <a:cs typeface="Calibri" pitchFamily="34" charset="-120"/>
               </a:rPr>
-              <a:t>Hours become minutes</a:t>
-            </a:r>
-            <a:endParaRPr lang="en-US" sz="1650" dirty="0"/>
-          </a:p>
-        </p:txBody>
-      </p:sp>
-      <p:sp>
-        <p:nvSpPr>
-          <p:cNvPr id="21" name="Text 17"/>
-          <p:cNvSpPr/>
-          <p:nvPr/>
-        </p:nvSpPr>
-        <p:spPr>
-          <a:xfrm>
-            <a:off x="4553712" y="4434840"/>
-            <a:ext cx="3054096" cy="1051560"/>
+              <a:t>B2B operator SaaS</a:t>
+            </a:r>
+            <a:endParaRPr lang="en-US" sz="1800" dirty="0"/>
+          </a:p>
+        </p:txBody>
+      </p:sp>
+      <p:sp>
+        <p:nvSpPr>
+          <p:cNvPr id="17" name="Text 13"/>
+          <p:cNvSpPr/>
+          <p:nvPr/>
+        </p:nvSpPr>
+        <p:spPr>
+          <a:xfrm>
+            <a:off x="6702552" y="2788920"/>
+            <a:ext cx="4645152" cy="621792"/>
+          </a:xfrm>
+          <a:prstGeom prst="rect">
+            <a:avLst/>
+          </a:prstGeom>
+          <a:noFill/>
+          <a:ln/>
+        </p:spPr>
+        <p:txBody>
+          <a:bodyPr wrap="square" lIns="0" tIns="0" rIns="0" bIns="0" rtlCol="0" anchor="ctr"/>
+          <a:lstStyle/>
+          <a:p>
+            <a:pPr indent="0" marL="0">
+              <a:buNone/>
+            </a:pPr>
+            <a:r>
+              <a:rPr lang="en-US" sz="3800" b="1" dirty="0">
+                <a:solidFill>
+                  <a:srgbClr val="02C39A"/>
+                </a:solidFill>
+                <a:latin typeface="Calibri" pitchFamily="34" charset="0"/>
+                <a:ea typeface="Calibri" pitchFamily="34" charset="-122"/>
+                <a:cs typeface="Calibri" pitchFamily="34" charset="-120"/>
+              </a:rPr>
+              <a:t>New revenue</a:t>
+            </a:r>
+            <a:endParaRPr lang="en-US" sz="3800" dirty="0"/>
+          </a:p>
+        </p:txBody>
+      </p:sp>
+      <p:sp>
+        <p:nvSpPr>
+          <p:cNvPr id="18" name="Text 14"/>
+          <p:cNvSpPr/>
+          <p:nvPr/>
+        </p:nvSpPr>
+        <p:spPr>
+          <a:xfrm>
+            <a:off x="6702552" y="3429000"/>
+            <a:ext cx="4645152" cy="292608"/>
+          </a:xfrm>
+          <a:prstGeom prst="rect">
+            <a:avLst/>
+          </a:prstGeom>
+          <a:noFill/>
+          <a:ln/>
+        </p:spPr>
+        <p:txBody>
+          <a:bodyPr wrap="square" lIns="0" tIns="0" rIns="0" bIns="0" rtlCol="0" anchor="ctr"/>
+          <a:lstStyle/>
+          <a:p>
+            <a:pPr indent="0" marL="0">
+              <a:buNone/>
+            </a:pPr>
+            <a:r>
+              <a:rPr lang="en-US" sz="1200" dirty="0">
+                <a:solidFill>
+                  <a:srgbClr val="CADCFC"/>
+                </a:solidFill>
+                <a:latin typeface="Calibri" pitchFamily="34" charset="0"/>
+                <a:ea typeface="Calibri" pitchFamily="34" charset="-122"/>
+                <a:cs typeface="Calibri" pitchFamily="34" charset="-120"/>
+              </a:rPr>
+              <a:t>from licensing PrimeNet to global operators</a:t>
+            </a:r>
+            <a:endParaRPr lang="en-US" sz="1200" dirty="0"/>
+          </a:p>
+        </p:txBody>
+      </p:sp>
+      <p:sp>
+        <p:nvSpPr>
+          <p:cNvPr id="19" name="Text 15"/>
+          <p:cNvSpPr/>
+          <p:nvPr/>
+        </p:nvSpPr>
+        <p:spPr>
+          <a:xfrm>
+            <a:off x="6793992" y="3931920"/>
+            <a:ext cx="4498848" cy="1188720"/>
           </a:xfrm>
           <a:prstGeom prst="rect">
             <a:avLst/>
@@ -3411,8 +3754,12 @@
           <a:bodyPr wrap="square" lIns="0" tIns="0" rIns="0" bIns="0" rtlCol="0" anchor="t"/>
           <a:lstStyle/>
           <a:p>
-            <a:pPr indent="0" marL="0">
-              <a:buNone/>
+            <a:pPr marL="152400" indent="-152400">
+              <a:spcAft>
+                <a:spcPts val="600"/>
+              </a:spcAft>
+              <a:buSzPct val="100000"/>
+              <a:buChar char="•"/>
             </a:pPr>
             <a:r>
               <a:rPr lang="en-US" sz="1250" dirty="0">
@@ -3423,57 +3770,119 @@
                 <a:ea typeface="Calibri" pitchFamily="34" charset="-122"/>
                 <a:cs typeface="Calibri" pitchFamily="34" charset="-120"/>
               </a:rPr>
-              <a:t>Morning reports, parameter audits and bulk config extraction that used to take an engineer's morning now run themselves.</a:t>
+              <a:t>Architected to scale as a standalone, integrated system</a:t>
             </a:r>
             <a:endParaRPr lang="en-US" sz="1250" dirty="0"/>
           </a:p>
-        </p:txBody>
-      </p:sp>
-      <p:sp>
-        <p:nvSpPr>
-          <p:cNvPr id="22" name="Shape 18"/>
-          <p:cNvSpPr/>
-          <p:nvPr/>
-        </p:nvSpPr>
-        <p:spPr>
-          <a:xfrm>
-            <a:off x="7973568" y="3063240"/>
-            <a:ext cx="3639312" cy="2514600"/>
+          <a:p>
+            <a:pPr marL="152400" indent="-152400">
+              <a:spcAft>
+                <a:spcPts val="600"/>
+              </a:spcAft>
+              <a:buSzPct val="100000"/>
+              <a:buChar char="•"/>
+            </a:pPr>
+            <a:r>
+              <a:rPr lang="en-US" sz="1250" dirty="0">
+                <a:solidFill>
+                  <a:srgbClr val="CADCFC"/>
+                </a:solidFill>
+                <a:latin typeface="Calibri" pitchFamily="34" charset="0"/>
+                <a:ea typeface="Calibri" pitchFamily="34" charset="-122"/>
+                <a:cs typeface="Calibri" pitchFamily="34" charset="-120"/>
+              </a:rPr>
+              <a:t>Licensed to global telecom operators</a:t>
+            </a:r>
+            <a:endParaRPr lang="en-US" sz="1250" dirty="0"/>
+          </a:p>
+          <a:p>
+            <a:pPr marL="152400" indent="-152400">
+              <a:spcAft>
+                <a:spcPts val="600"/>
+              </a:spcAft>
+              <a:buSzPct val="100000"/>
+              <a:buChar char="•"/>
+            </a:pPr>
+            <a:r>
+              <a:rPr lang="en-US" sz="1250" dirty="0">
+                <a:solidFill>
+                  <a:srgbClr val="CADCFC"/>
+                </a:solidFill>
+                <a:latin typeface="Calibri" pitchFamily="34" charset="0"/>
+                <a:ea typeface="Calibri" pitchFamily="34" charset="-122"/>
+                <a:cs typeface="Calibri" pitchFamily="34" charset="-120"/>
+              </a:rPr>
+              <a:t>Turns a cost center into a major revenue stream</a:t>
+            </a:r>
+            <a:endParaRPr lang="en-US" sz="1250" dirty="0"/>
+          </a:p>
+        </p:txBody>
+      </p:sp>
+      <p:sp>
+        <p:nvSpPr>
+          <p:cNvPr id="20" name="Shape 16"/>
+          <p:cNvSpPr/>
+          <p:nvPr/>
+        </p:nvSpPr>
+        <p:spPr>
+          <a:xfrm rot="5400000">
+            <a:off x="5888736" y="3278124"/>
+            <a:ext cx="411480" cy="365760"/>
+          </a:xfrm>
+          <a:prstGeom prst="triangle">
+            <a:avLst/>
+          </a:prstGeom>
+          <a:solidFill>
+            <a:srgbClr val="02C39A"/>
+          </a:solidFill>
+          <a:ln/>
+        </p:spPr>
+      </p:sp>
+      <p:sp>
+        <p:nvSpPr>
+          <p:cNvPr id="21" name="Shape 17"/>
+          <p:cNvSpPr/>
+          <p:nvPr/>
+        </p:nvSpPr>
+        <p:spPr>
+          <a:xfrm>
+            <a:off x="548640" y="5623560"/>
+            <a:ext cx="11091672" cy="731520"/>
           </a:xfrm>
           <a:prstGeom prst="roundRect">
             <a:avLst>
-              <a:gd name="adj" fmla="val 3273"/>
+              <a:gd name="adj" fmla="val 11250"/>
             </a:avLst>
           </a:prstGeom>
           <a:solidFill>
-            <a:srgbClr val="2A3575"/>
-          </a:solidFill>
-          <a:ln/>
-        </p:spPr>
-      </p:sp>
-      <p:sp>
-        <p:nvSpPr>
-          <p:cNvPr id="23" name="Shape 19"/>
-          <p:cNvSpPr/>
-          <p:nvPr/>
-        </p:nvSpPr>
-        <p:spPr>
-          <a:xfrm>
-            <a:off x="8266176" y="3355848"/>
-            <a:ext cx="566928" cy="566928"/>
+            <a:srgbClr val="02C39A"/>
+          </a:solidFill>
+          <a:ln/>
+        </p:spPr>
+      </p:sp>
+      <p:sp>
+        <p:nvSpPr>
+          <p:cNvPr id="22" name="Shape 18"/>
+          <p:cNvSpPr/>
+          <p:nvPr/>
+        </p:nvSpPr>
+        <p:spPr>
+          <a:xfrm>
+            <a:off x="868680" y="5760720"/>
+            <a:ext cx="457200" cy="457200"/>
           </a:xfrm>
           <a:prstGeom prst="ellipse">
             <a:avLst/>
           </a:prstGeom>
           <a:solidFill>
-            <a:srgbClr val="02C39A"/>
+            <a:srgbClr val="1E2761"/>
           </a:solidFill>
           <a:ln/>
         </p:spPr>
       </p:sp>
       <p:pic>
         <p:nvPicPr>
-          <p:cNvPr id="24" name="Image 2" descr="preencoded.png">    </p:cNvPr>
+          <p:cNvPr id="23" name="Image 2" descr="preencoded.png">    </p:cNvPr>
           <p:cNvPicPr>
             <a:picLocks noChangeAspect="1"/>
           </p:cNvPicPr>
@@ -3487,8 +3896,8 @@
         </p:blipFill>
         <p:spPr>
           <a:xfrm>
-            <a:off x="8402239" y="3491911"/>
-            <a:ext cx="294803" cy="294803"/>
+            <a:off x="978408" y="5870448"/>
+            <a:ext cx="237744" cy="237744"/>
           </a:xfrm>
           <a:prstGeom prst="rect">
             <a:avLst/>
@@ -3497,14 +3906,14 @@
       </p:pic>
       <p:sp>
         <p:nvSpPr>
-          <p:cNvPr id="25" name="Text 20"/>
-          <p:cNvSpPr/>
-          <p:nvPr/>
-        </p:nvSpPr>
-        <p:spPr>
-          <a:xfrm>
-            <a:off x="8266176" y="4050792"/>
-            <a:ext cx="3054096" cy="365760"/>
+          <p:cNvPr id="24" name="Text 19"/>
+          <p:cNvSpPr/>
+          <p:nvPr/>
+        </p:nvSpPr>
+        <p:spPr>
+          <a:xfrm>
+            <a:off x="1508760" y="5623560"/>
+            <a:ext cx="9966960" cy="731520"/>
           </a:xfrm>
           <a:prstGeom prst="rect">
             <a:avLst/>
@@ -3520,95 +3929,31 @@
               <a:buNone/>
             </a:pPr>
             <a:r>
-              <a:rPr lang="en-US" sz="1650" b="1" dirty="0">
-                <a:solidFill>
-                  <a:srgbClr val="FFFFFF"/>
-                </a:solidFill>
-                <a:latin typeface="Calibri" pitchFamily="34" charset="0"/>
-                <a:ea typeface="Calibri" pitchFamily="34" charset="-122"/>
-                <a:cs typeface="Calibri" pitchFamily="34" charset="-120"/>
-              </a:rPr>
-              <a:t>Independence &amp; control</a:t>
-            </a:r>
-            <a:endParaRPr lang="en-US" sz="1650" dirty="0"/>
-          </a:p>
-        </p:txBody>
-      </p:sp>
-      <p:sp>
-        <p:nvSpPr>
-          <p:cNvPr id="26" name="Text 21"/>
-          <p:cNvSpPr/>
-          <p:nvPr/>
-        </p:nvSpPr>
-        <p:spPr>
-          <a:xfrm>
-            <a:off x="8266176" y="4434840"/>
-            <a:ext cx="3054096" cy="1051560"/>
-          </a:xfrm>
-          <a:prstGeom prst="rect">
-            <a:avLst/>
-          </a:prstGeom>
-          <a:noFill/>
-          <a:ln/>
-        </p:spPr>
-        <p:txBody>
-          <a:bodyPr wrap="square" lIns="0" tIns="0" rIns="0" bIns="0" rtlCol="0" anchor="t"/>
-          <a:lstStyle/>
-          <a:p>
+              <a:rPr lang="en-US" sz="1550" b="1" dirty="0">
+                <a:solidFill>
+                  <a:srgbClr val="1E2761"/>
+                </a:solidFill>
+                <a:latin typeface="Calibri" pitchFamily="34" charset="0"/>
+                <a:ea typeface="Calibri" pitchFamily="34" charset="-122"/>
+                <a:cs typeface="Calibri" pitchFamily="34" charset="-120"/>
+              </a:rPr>
+              <a:t>The ask:  </a:t>
+            </a:r>
             <a:pPr indent="0" marL="0">
               <a:buNone/>
             </a:pPr>
             <a:r>
-              <a:rPr lang="en-US" sz="1250" dirty="0">
-                <a:solidFill>
-                  <a:srgbClr val="CADCFC"/>
-                </a:solidFill>
-                <a:latin typeface="Calibri" pitchFamily="34" charset="0"/>
-                <a:ea typeface="Calibri" pitchFamily="34" charset="-122"/>
-                <a:cs typeface="Calibri" pitchFamily="34" charset="-120"/>
-              </a:rPr>
-              <a:t>Built in-house and running on-prem: our data stays ours, there are no per-seat vendor licenses, and new tools are added as modules — not purchases.</a:t>
-            </a:r>
-            <a:endParaRPr lang="en-US" sz="1250" dirty="0"/>
-          </a:p>
-        </p:txBody>
-      </p:sp>
-      <p:sp>
-        <p:nvSpPr>
-          <p:cNvPr id="27" name="Text 22"/>
-          <p:cNvSpPr/>
-          <p:nvPr/>
-        </p:nvSpPr>
-        <p:spPr>
-          <a:xfrm>
-            <a:off x="548640" y="5989320"/>
-            <a:ext cx="11064240" cy="411480"/>
-          </a:xfrm>
-          <a:prstGeom prst="rect">
-            <a:avLst/>
-          </a:prstGeom>
-          <a:noFill/>
-          <a:ln/>
-        </p:spPr>
-        <p:txBody>
-          <a:bodyPr wrap="square" lIns="0" tIns="0" rIns="0" bIns="0" rtlCol="0" anchor="ctr"/>
-          <a:lstStyle/>
-          <a:p>
-            <a:pPr indent="0" marL="0">
-              <a:buNone/>
-            </a:pPr>
-            <a:r>
-              <a:rPr lang="en-US" sz="1450" i="1" dirty="0">
-                <a:solidFill>
-                  <a:srgbClr val="CADCFC"/>
-                </a:solidFill>
-                <a:latin typeface="Calibri" pitchFamily="34" charset="0"/>
-                <a:ea typeface="Calibri" pitchFamily="34" charset="-122"/>
-                <a:cs typeface="Calibri" pitchFamily="34" charset="-120"/>
-              </a:rPr>
-              <a:t>PrimeNet turns raw network data into engineering decisions — faster, cheaper, and on our own terms.</a:t>
-            </a:r>
-            <a:endParaRPr lang="en-US" sz="1450" dirty="0"/>
+              <a:rPr lang="en-US" sz="1550" dirty="0">
+                <a:solidFill>
+                  <a:srgbClr val="1E2761"/>
+                </a:solidFill>
+                <a:latin typeface="Calibri" pitchFamily="34" charset="0"/>
+                <a:ea typeface="Calibri" pitchFamily="34" charset="-122"/>
+                <a:cs typeface="Calibri" pitchFamily="34" charset="-120"/>
+              </a:rPr>
+              <a:t>green-light a 30-day pilot with [X team] to prove the Phase 1 savings.</a:t>
+            </a:r>
+            <a:endParaRPr lang="en-US" sz="1550" dirty="0"/>
           </a:p>
         </p:txBody>
       </p:sp>

</xml_diff>